<commit_message>
Update Coverity slide: remove header/footer branding, update subtitle, and streamline flow without Stage 3
Co-authored-by: arena-agent <297053741+arena-agent@users.noreply.github.com>
</commit_message>
<xml_diff>
--- a/Coverity_Findings_Analyzer.pptx
+++ b/Coverity_Findings_Analyzer.pptx
@@ -6,9 +6,8 @@
   </p:sldMasterIdLst>
   <p:sldIdLst>
     <p:sldId id="256" r:id="rId7"/>
-    <p:sldId id="257" r:id="rId8"/>
   </p:sldIdLst>
-  <p:sldSz cx="9144000" cy="6858000" type="screen4x3"/>
+  <p:sldSz cx="12191695" cy="6858000" type="screen4x3"/>
   <p:notesSz cx="6858000" cy="9144000"/>
   <p:defaultTextStyle>
     <a:defPPr>
@@ -3082,6 +3081,14 @@
 <file path=ppt/slides/slide1.xml><?xml version="1.0" encoding="utf-8"?>
 <p:sld xmlns:a="http://schemas.openxmlformats.org/drawingml/2006/main" xmlns:p="http://schemas.openxmlformats.org/presentationml/2006/main" xmlns:r="http://schemas.openxmlformats.org/officeDocument/2006/relationships">
   <p:cSld>
+    <p:bg>
+      <p:bgPr>
+        <a:solidFill>
+          <a:srgbClr val="0A0E1A"/>
+        </a:solidFill>
+        <a:effectLst/>
+      </p:bgPr>
+    </p:bg>
     <p:spTree>
       <p:nvGrpSpPr>
         <p:cNvPr id="1" name=""/>
@@ -3091,178 +3098,1923 @@
       <p:grpSpPr/>
       <p:sp>
         <p:nvSpPr>
-          <p:cNvPr id="2" name="Title 1"/>
-          <p:cNvSpPr>
-            <a:spLocks noGrp="1"/>
-          </p:cNvSpPr>
-          <p:nvPr>
-            <p:ph type="ctrTitle"/>
-          </p:nvPr>
-        </p:nvSpPr>
-        <p:spPr/>
-        <p:txBody>
-          <a:bodyPr/>
+          <p:cNvPr id="2" name="Oval 1"/>
+          <p:cNvSpPr/>
+          <p:nvPr/>
+        </p:nvSpPr>
+        <p:spPr>
+          <a:xfrm>
+            <a:off x="2377440" y="109728"/>
+            <a:ext cx="411480" cy="411480"/>
+          </a:xfrm>
+          <a:prstGeom prst="ellipse">
+            <a:avLst/>
+          </a:prstGeom>
+          <a:solidFill>
+            <a:srgbClr val="FF6B00"/>
+          </a:solidFill>
+          <a:ln>
+            <a:noFill/>
+          </a:ln>
+        </p:spPr>
+        <p:style>
+          <a:lnRef idx="1">
+            <a:schemeClr val="accent1"/>
+          </a:lnRef>
+          <a:fillRef idx="3">
+            <a:schemeClr val="accent1"/>
+          </a:fillRef>
+          <a:effectRef idx="2">
+            <a:schemeClr val="accent1"/>
+          </a:effectRef>
+          <a:fontRef idx="minor">
+            <a:schemeClr val="lt1"/>
+          </a:fontRef>
+        </p:style>
+        <p:txBody>
+          <a:bodyPr rtlCol="0" anchor="ctr"/>
+          <a:lstStyle/>
+          <a:p>
+            <a:pPr algn="ctr"/>
+          </a:p>
+        </p:txBody>
+      </p:sp>
+      <p:sp>
+        <p:nvSpPr>
+          <p:cNvPr id="3" name="TextBox 2"/>
+          <p:cNvSpPr txBox="1"/>
+          <p:nvPr/>
+        </p:nvSpPr>
+        <p:spPr>
+          <a:xfrm>
+            <a:off x="2834640" y="45720"/>
+            <a:ext cx="6858000" cy="457200"/>
+          </a:xfrm>
+          <a:prstGeom prst="rect">
+            <a:avLst/>
+          </a:prstGeom>
+          <a:noFill/>
+        </p:spPr>
+        <p:txBody>
+          <a:bodyPr wrap="square" anchor="t">
+            <a:spAutoFit/>
+          </a:bodyPr>
+          <a:lstStyle/>
+          <a:p>
+            <a:pPr algn="l">
+              <a:defRPr sz="2600" b="1">
+                <a:solidFill>
+                  <a:srgbClr val="FF6B00"/>
+                </a:solidFill>
+                <a:latin typeface="Calibri"/>
+              </a:defRPr>
+            </a:pPr>
+            <a:r>
+              <a:t>COVERITY FINDINGS ANALYZER</a:t>
+            </a:r>
+          </a:p>
+        </p:txBody>
+      </p:sp>
+      <p:sp>
+        <p:nvSpPr>
+          <p:cNvPr id="4" name="TextBox 3"/>
+          <p:cNvSpPr txBox="1"/>
+          <p:nvPr/>
+        </p:nvSpPr>
+        <p:spPr>
+          <a:xfrm>
+            <a:off x="1828800" y="502920"/>
+            <a:ext cx="8534095" cy="365760"/>
+          </a:xfrm>
+          <a:prstGeom prst="rect">
+            <a:avLst/>
+          </a:prstGeom>
+          <a:noFill/>
+        </p:spPr>
+        <p:txBody>
+          <a:bodyPr wrap="square" anchor="t">
+            <a:spAutoFit/>
+          </a:bodyPr>
+          <a:lstStyle/>
+          <a:p>
+            <a:pPr algn="ctr">
+              <a:defRPr sz="1400" b="0">
+                <a:solidFill>
+                  <a:srgbClr val="CCCCDD"/>
+                </a:solidFill>
+                <a:latin typeface="Calibri"/>
+              </a:defRPr>
+            </a:pPr>
+            <a:r>
+              <a:t>AI-Developed, Rule-Based Static Analysis</a:t>
+            </a:r>
+          </a:p>
+        </p:txBody>
+      </p:sp>
+      <p:sp>
+        <p:nvSpPr>
+          <p:cNvPr id="5" name="Rectangle 4"/>
+          <p:cNvSpPr/>
+          <p:nvPr/>
+        </p:nvSpPr>
+        <p:spPr>
+          <a:xfrm>
+            <a:off x="274320" y="868680"/>
+            <a:ext cx="11612880" cy="18288"/>
+          </a:xfrm>
+          <a:prstGeom prst="rect">
+            <a:avLst/>
+          </a:prstGeom>
+          <a:solidFill>
+            <a:srgbClr val="FF6B00"/>
+          </a:solidFill>
+          <a:ln>
+            <a:noFill/>
+          </a:ln>
+        </p:spPr>
+        <p:style>
+          <a:lnRef idx="1">
+            <a:schemeClr val="accent1"/>
+          </a:lnRef>
+          <a:fillRef idx="3">
+            <a:schemeClr val="accent1"/>
+          </a:fillRef>
+          <a:effectRef idx="2">
+            <a:schemeClr val="accent1"/>
+          </a:effectRef>
+          <a:fontRef idx="minor">
+            <a:schemeClr val="lt1"/>
+          </a:fontRef>
+        </p:style>
+        <p:txBody>
+          <a:bodyPr rtlCol="0" anchor="ctr"/>
+          <a:lstStyle/>
+          <a:p>
+            <a:pPr algn="ctr"/>
+          </a:p>
+        </p:txBody>
+      </p:sp>
+      <p:sp>
+        <p:nvSpPr>
+          <p:cNvPr id="6" name="TextBox 5"/>
+          <p:cNvSpPr txBox="1"/>
+          <p:nvPr/>
+        </p:nvSpPr>
+        <p:spPr>
+          <a:xfrm>
+            <a:off x="365760" y="1051560"/>
+            <a:ext cx="3657600" cy="320040"/>
+          </a:xfrm>
+          <a:prstGeom prst="rect">
+            <a:avLst/>
+          </a:prstGeom>
+          <a:noFill/>
+        </p:spPr>
+        <p:txBody>
+          <a:bodyPr wrap="square" anchor="t">
+            <a:spAutoFit/>
+          </a:bodyPr>
+          <a:lstStyle/>
+          <a:p>
+            <a:pPr algn="l">
+              <a:defRPr sz="1600" b="1">
+                <a:solidFill>
+                  <a:srgbClr val="FF6B00"/>
+                </a:solidFill>
+                <a:latin typeface="Calibri"/>
+              </a:defRPr>
+            </a:pPr>
+            <a:r>
+              <a:t>  CORE FEATURES</a:t>
+            </a:r>
+          </a:p>
+        </p:txBody>
+      </p:sp>
+      <p:sp>
+        <p:nvSpPr>
+          <p:cNvPr id="7" name="TextBox 6"/>
+          <p:cNvSpPr txBox="1"/>
+          <p:nvPr/>
+        </p:nvSpPr>
+        <p:spPr>
+          <a:xfrm>
+            <a:off x="457200" y="1417320"/>
+            <a:ext cx="3474720" cy="201168"/>
+          </a:xfrm>
+          <a:prstGeom prst="rect">
+            <a:avLst/>
+          </a:prstGeom>
+          <a:noFill/>
+        </p:spPr>
+        <p:txBody>
+          <a:bodyPr wrap="square" anchor="t">
+            <a:spAutoFit/>
+          </a:bodyPr>
+          <a:lstStyle/>
+          <a:p>
+            <a:pPr algn="l">
+              <a:defRPr sz="1100" b="1">
+                <a:solidFill>
+                  <a:srgbClr val="FFFFFF"/>
+                </a:solidFill>
+                <a:latin typeface="Calibri"/>
+              </a:defRPr>
+            </a:pPr>
+            <a:r>
+              <a:t>Aerospace Compliance</a:t>
+            </a:r>
+          </a:p>
+        </p:txBody>
+      </p:sp>
+      <p:sp>
+        <p:nvSpPr>
+          <p:cNvPr id="8" name="TextBox 7"/>
+          <p:cNvSpPr txBox="1"/>
+          <p:nvPr/>
+        </p:nvSpPr>
+        <p:spPr>
+          <a:xfrm>
+            <a:off x="457200" y="1600200"/>
+            <a:ext cx="3474720" cy="201168"/>
+          </a:xfrm>
+          <a:prstGeom prst="rect">
+            <a:avLst/>
+          </a:prstGeom>
+          <a:noFill/>
+        </p:spPr>
+        <p:txBody>
+          <a:bodyPr wrap="square" anchor="t">
+            <a:spAutoFit/>
+          </a:bodyPr>
+          <a:lstStyle/>
+          <a:p>
+            <a:pPr algn="l">
+              <a:defRPr sz="1000" b="0">
+                <a:solidFill>
+                  <a:srgbClr val="CCCCDD"/>
+                </a:solidFill>
+                <a:latin typeface="Calibri"/>
+              </a:defRPr>
+            </a:pPr>
+            <a:r>
+              <a:t>  DO-178C, MISRA, CERT</a:t>
+            </a:r>
+          </a:p>
+        </p:txBody>
+      </p:sp>
+      <p:sp>
+        <p:nvSpPr>
+          <p:cNvPr id="9" name="TextBox 8"/>
+          <p:cNvSpPr txBox="1"/>
+          <p:nvPr/>
+        </p:nvSpPr>
+        <p:spPr>
+          <a:xfrm>
+            <a:off x="457200" y="1965960"/>
+            <a:ext cx="3474720" cy="201168"/>
+          </a:xfrm>
+          <a:prstGeom prst="rect">
+            <a:avLst/>
+          </a:prstGeom>
+          <a:noFill/>
+        </p:spPr>
+        <p:txBody>
+          <a:bodyPr wrap="square" anchor="t">
+            <a:spAutoFit/>
+          </a:bodyPr>
+          <a:lstStyle/>
+          <a:p>
+            <a:pPr algn="l">
+              <a:defRPr sz="1100" b="1">
+                <a:solidFill>
+                  <a:srgbClr val="FFFFFF"/>
+                </a:solidFill>
+                <a:latin typeface="Calibri"/>
+              </a:defRPr>
+            </a:pPr>
+            <a:r>
+              <a:t>100% Secure &amp; Offline</a:t>
+            </a:r>
+          </a:p>
+        </p:txBody>
+      </p:sp>
+      <p:sp>
+        <p:nvSpPr>
+          <p:cNvPr id="10" name="TextBox 9"/>
+          <p:cNvSpPr txBox="1"/>
+          <p:nvPr/>
+        </p:nvSpPr>
+        <p:spPr>
+          <a:xfrm>
+            <a:off x="457200" y="2148840"/>
+            <a:ext cx="3474720" cy="201168"/>
+          </a:xfrm>
+          <a:prstGeom prst="rect">
+            <a:avLst/>
+          </a:prstGeom>
+          <a:noFill/>
+        </p:spPr>
+        <p:txBody>
+          <a:bodyPr wrap="square" anchor="t">
+            <a:spAutoFit/>
+          </a:bodyPr>
+          <a:lstStyle/>
+          <a:p>
+            <a:pPr algn="l">
+              <a:defRPr sz="1000" b="0">
+                <a:solidFill>
+                  <a:srgbClr val="CCCCDD"/>
+                </a:solidFill>
+                <a:latin typeface="Calibri"/>
+              </a:defRPr>
+            </a:pPr>
+            <a:r>
+              <a:t>  Source never leaves machine</a:t>
+            </a:r>
+          </a:p>
+        </p:txBody>
+      </p:sp>
+      <p:sp>
+        <p:nvSpPr>
+          <p:cNvPr id="11" name="TextBox 10"/>
+          <p:cNvSpPr txBox="1"/>
+          <p:nvPr/>
+        </p:nvSpPr>
+        <p:spPr>
+          <a:xfrm>
+            <a:off x="457200" y="2514600"/>
+            <a:ext cx="3474720" cy="201168"/>
+          </a:xfrm>
+          <a:prstGeom prst="rect">
+            <a:avLst/>
+          </a:prstGeom>
+          <a:noFill/>
+        </p:spPr>
+        <p:txBody>
+          <a:bodyPr wrap="square" anchor="t">
+            <a:spAutoFit/>
+          </a:bodyPr>
+          <a:lstStyle/>
+          <a:p>
+            <a:pPr algn="l">
+              <a:defRPr sz="1100" b="1">
+                <a:solidFill>
+                  <a:srgbClr val="FFFFFF"/>
+                </a:solidFill>
+                <a:latin typeface="Calibri"/>
+              </a:defRPr>
+            </a:pPr>
+            <a:r>
+              <a:t>No AI Tokens Required</a:t>
+            </a:r>
+          </a:p>
+        </p:txBody>
+      </p:sp>
+      <p:sp>
+        <p:nvSpPr>
+          <p:cNvPr id="12" name="TextBox 11"/>
+          <p:cNvSpPr txBox="1"/>
+          <p:nvPr/>
+        </p:nvSpPr>
+        <p:spPr>
+          <a:xfrm>
+            <a:off x="457200" y="2697480"/>
+            <a:ext cx="3474720" cy="201168"/>
+          </a:xfrm>
+          <a:prstGeom prst="rect">
+            <a:avLst/>
+          </a:prstGeom>
+          <a:noFill/>
+        </p:spPr>
+        <p:txBody>
+          <a:bodyPr wrap="square" anchor="t">
+            <a:spAutoFit/>
+          </a:bodyPr>
+          <a:lstStyle/>
+          <a:p>
+            <a:pPr algn="l">
+              <a:defRPr sz="1000" b="0">
+                <a:solidFill>
+                  <a:srgbClr val="CCCCDD"/>
+                </a:solidFill>
+                <a:latin typeface="Calibri"/>
+              </a:defRPr>
+            </a:pPr>
+            <a:r>
+              <a:t>  Runs 100% offline</a:t>
+            </a:r>
+          </a:p>
+        </p:txBody>
+      </p:sp>
+      <p:sp>
+        <p:nvSpPr>
+          <p:cNvPr id="13" name="TextBox 12"/>
+          <p:cNvSpPr txBox="1"/>
+          <p:nvPr/>
+        </p:nvSpPr>
+        <p:spPr>
+          <a:xfrm>
+            <a:off x="457200" y="3063240"/>
+            <a:ext cx="3474720" cy="201168"/>
+          </a:xfrm>
+          <a:prstGeom prst="rect">
+            <a:avLst/>
+          </a:prstGeom>
+          <a:noFill/>
+        </p:spPr>
+        <p:txBody>
+          <a:bodyPr wrap="square" anchor="t">
+            <a:spAutoFit/>
+          </a:bodyPr>
+          <a:lstStyle/>
+          <a:p>
+            <a:pPr algn="l">
+              <a:defRPr sz="1100" b="1">
+                <a:solidFill>
+                  <a:srgbClr val="FFFFFF"/>
+                </a:solidFill>
+                <a:latin typeface="Calibri"/>
+              </a:defRPr>
+            </a:pPr>
+            <a:r>
+              <a:t>Reduces SME Dependency</a:t>
+            </a:r>
+          </a:p>
+        </p:txBody>
+      </p:sp>
+      <p:sp>
+        <p:nvSpPr>
+          <p:cNvPr id="14" name="TextBox 13"/>
+          <p:cNvSpPr txBox="1"/>
+          <p:nvPr/>
+        </p:nvSpPr>
+        <p:spPr>
+          <a:xfrm>
+            <a:off x="457200" y="3246120"/>
+            <a:ext cx="3474720" cy="201168"/>
+          </a:xfrm>
+          <a:prstGeom prst="rect">
+            <a:avLst/>
+          </a:prstGeom>
+          <a:noFill/>
+        </p:spPr>
+        <p:txBody>
+          <a:bodyPr wrap="square" anchor="t">
+            <a:spAutoFit/>
+          </a:bodyPr>
+          <a:lstStyle/>
+          <a:p>
+            <a:pPr algn="l">
+              <a:defRPr sz="1000" b="0">
+                <a:solidFill>
+                  <a:srgbClr val="CCCCDD"/>
+                </a:solidFill>
+                <a:latin typeface="Calibri"/>
+              </a:defRPr>
+            </a:pPr>
+            <a:r>
+              <a:t>  80% reduction</a:t>
+            </a:r>
+          </a:p>
+        </p:txBody>
+      </p:sp>
+      <p:sp>
+        <p:nvSpPr>
+          <p:cNvPr id="15" name="TextBox 14"/>
+          <p:cNvSpPr txBox="1"/>
+          <p:nvPr/>
+        </p:nvSpPr>
+        <p:spPr>
+          <a:xfrm>
+            <a:off x="4206240" y="1051560"/>
+            <a:ext cx="3200400" cy="320040"/>
+          </a:xfrm>
+          <a:prstGeom prst="rect">
+            <a:avLst/>
+          </a:prstGeom>
+          <a:noFill/>
+        </p:spPr>
+        <p:txBody>
+          <a:bodyPr wrap="square" anchor="t">
+            <a:spAutoFit/>
+          </a:bodyPr>
+          <a:lstStyle/>
+          <a:p>
+            <a:pPr algn="l">
+              <a:defRPr sz="1600" b="1">
+                <a:solidFill>
+                  <a:srgbClr val="FF6B00"/>
+                </a:solidFill>
+                <a:latin typeface="Calibri"/>
+              </a:defRPr>
+            </a:pPr>
+            <a:r>
+              <a:t>⚖  WORK DETAILS</a:t>
+            </a:r>
+          </a:p>
+        </p:txBody>
+      </p:sp>
+      <p:sp>
+        <p:nvSpPr>
+          <p:cNvPr id="16" name="Rounded Rectangle 15"/>
+          <p:cNvSpPr/>
+          <p:nvPr/>
+        </p:nvSpPr>
+        <p:spPr>
+          <a:xfrm>
+            <a:off x="4206240" y="1417320"/>
+            <a:ext cx="2103120" cy="384048"/>
+          </a:xfrm>
+          <a:prstGeom prst="roundRect">
+            <a:avLst/>
+          </a:prstGeom>
+          <a:solidFill>
+            <a:srgbClr val="3A1515"/>
+          </a:solidFill>
+          <a:ln w="12700">
+            <a:solidFill>
+              <a:srgbClr val="FF6B00"/>
+            </a:solidFill>
+          </a:ln>
+        </p:spPr>
+        <p:style>
+          <a:lnRef idx="1">
+            <a:schemeClr val="accent1"/>
+          </a:lnRef>
+          <a:fillRef idx="3">
+            <a:schemeClr val="accent1"/>
+          </a:fillRef>
+          <a:effectRef idx="2">
+            <a:schemeClr val="accent1"/>
+          </a:effectRef>
+          <a:fontRef idx="minor">
+            <a:schemeClr val="lt1"/>
+          </a:fontRef>
+        </p:style>
+        <p:txBody>
+          <a:bodyPr rtlCol="0" anchor="ctr"/>
+          <a:lstStyle/>
+          <a:p>
+            <a:pPr algn="ctr">
+              <a:defRPr sz="1100" b="1">
+                <a:solidFill>
+                  <a:srgbClr val="FF4444"/>
+                </a:solidFill>
+              </a:defRPr>
+            </a:pPr>
+            <a:r>
+              <a:t>MANUAL</a:t>
+            </a:r>
+          </a:p>
+        </p:txBody>
+      </p:sp>
+      <p:sp>
+        <p:nvSpPr>
+          <p:cNvPr id="17" name="Rounded Rectangle 16"/>
+          <p:cNvSpPr/>
+          <p:nvPr/>
+        </p:nvSpPr>
+        <p:spPr>
+          <a:xfrm>
+            <a:off x="6355079" y="1417320"/>
+            <a:ext cx="2103120" cy="384048"/>
+          </a:xfrm>
+          <a:prstGeom prst="roundRect">
+            <a:avLst/>
+          </a:prstGeom>
+          <a:solidFill>
+            <a:srgbClr val="0F2E1A"/>
+          </a:solidFill>
+          <a:ln w="12700">
+            <a:solidFill>
+              <a:srgbClr val="FF6B00"/>
+            </a:solidFill>
+          </a:ln>
+        </p:spPr>
+        <p:style>
+          <a:lnRef idx="1">
+            <a:schemeClr val="accent1"/>
+          </a:lnRef>
+          <a:fillRef idx="3">
+            <a:schemeClr val="accent1"/>
+          </a:fillRef>
+          <a:effectRef idx="2">
+            <a:schemeClr val="accent1"/>
+          </a:effectRef>
+          <a:fontRef idx="minor">
+            <a:schemeClr val="lt1"/>
+          </a:fontRef>
+        </p:style>
+        <p:txBody>
+          <a:bodyPr rtlCol="0" anchor="ctr"/>
+          <a:lstStyle/>
+          <a:p>
+            <a:pPr algn="ctr">
+              <a:defRPr sz="1100" b="1">
+                <a:solidFill>
+                  <a:srgbClr val="00CC66"/>
+                </a:solidFill>
+              </a:defRPr>
+            </a:pPr>
+            <a:r>
+              <a:t>WITH TOOL</a:t>
+            </a:r>
+          </a:p>
+        </p:txBody>
+      </p:sp>
+      <p:sp>
+        <p:nvSpPr>
+          <p:cNvPr id="18" name="Rounded Rectangle 17"/>
+          <p:cNvSpPr/>
+          <p:nvPr/>
+        </p:nvSpPr>
+        <p:spPr>
+          <a:xfrm>
+            <a:off x="4206240" y="1837943"/>
+            <a:ext cx="2103120" cy="384048"/>
+          </a:xfrm>
+          <a:prstGeom prst="roundRect">
+            <a:avLst/>
+          </a:prstGeom>
+          <a:solidFill>
+            <a:srgbClr val="3A1515"/>
+          </a:solidFill>
+          <a:ln>
+            <a:noFill/>
+          </a:ln>
+        </p:spPr>
+        <p:style>
+          <a:lnRef idx="1">
+            <a:schemeClr val="accent1"/>
+          </a:lnRef>
+          <a:fillRef idx="3">
+            <a:schemeClr val="accent1"/>
+          </a:fillRef>
+          <a:effectRef idx="2">
+            <a:schemeClr val="accent1"/>
+          </a:effectRef>
+          <a:fontRef idx="minor">
+            <a:schemeClr val="lt1"/>
+          </a:fontRef>
+        </p:style>
+        <p:txBody>
+          <a:bodyPr rtlCol="0" anchor="ctr" wrap="square"/>
           <a:lstStyle/>
           <a:p>
             <a:pPr>
-              <a:defRPr b="1" sz="4400"/>
+              <a:defRPr sz="900">
+                <a:solidFill>
+                  <a:srgbClr val="CCCCDD"/>
+                </a:solidFill>
+              </a:defRPr>
             </a:pPr>
             <a:r>
-              <a:t>🤖 COVERITY FINDINGS ANALYZER</a:t>
-            </a:r>
-          </a:p>
-        </p:txBody>
-      </p:sp>
-      <p:sp>
-        <p:nvSpPr>
-          <p:cNvPr id="3" name="Subtitle 2"/>
-          <p:cNvSpPr>
-            <a:spLocks noGrp="1"/>
-          </p:cNvSpPr>
-          <p:nvPr>
-            <p:ph type="subTitle" idx="1"/>
-          </p:nvPr>
-        </p:nvSpPr>
-        <p:spPr/>
-        <p:txBody>
-          <a:bodyPr/>
+              <a:t>⏱ 10-15 min / defect</a:t>
+            </a:r>
+          </a:p>
+        </p:txBody>
+      </p:sp>
+      <p:sp>
+        <p:nvSpPr>
+          <p:cNvPr id="19" name="Rounded Rectangle 18"/>
+          <p:cNvSpPr/>
+          <p:nvPr/>
+        </p:nvSpPr>
+        <p:spPr>
+          <a:xfrm>
+            <a:off x="6355079" y="1837943"/>
+            <a:ext cx="2103120" cy="384048"/>
+          </a:xfrm>
+          <a:prstGeom prst="roundRect">
+            <a:avLst/>
+          </a:prstGeom>
+          <a:solidFill>
+            <a:srgbClr val="0F2E1A"/>
+          </a:solidFill>
+          <a:ln>
+            <a:noFill/>
+          </a:ln>
+        </p:spPr>
+        <p:style>
+          <a:lnRef idx="1">
+            <a:schemeClr val="accent1"/>
+          </a:lnRef>
+          <a:fillRef idx="3">
+            <a:schemeClr val="accent1"/>
+          </a:fillRef>
+          <a:effectRef idx="2">
+            <a:schemeClr val="accent1"/>
+          </a:effectRef>
+          <a:fontRef idx="minor">
+            <a:schemeClr val="lt1"/>
+          </a:fontRef>
+        </p:style>
+        <p:txBody>
+          <a:bodyPr rtlCol="0" anchor="ctr" wrap="square"/>
           <a:lstStyle/>
           <a:p>
             <a:pPr>
+              <a:defRPr sz="900">
+                <a:solidFill>
+                  <a:srgbClr val="FFFFFF"/>
+                </a:solidFill>
+              </a:defRPr>
+            </a:pPr>
+            <a:r>
+              <a:t>⚡ 1-2 min / defect</a:t>
+            </a:r>
+          </a:p>
+        </p:txBody>
+      </p:sp>
+      <p:sp>
+        <p:nvSpPr>
+          <p:cNvPr id="20" name="Rounded Rectangle 19"/>
+          <p:cNvSpPr/>
+          <p:nvPr/>
+        </p:nvSpPr>
+        <p:spPr>
+          <a:xfrm>
+            <a:off x="4206240" y="2258568"/>
+            <a:ext cx="2103120" cy="384048"/>
+          </a:xfrm>
+          <a:prstGeom prst="roundRect">
+            <a:avLst/>
+          </a:prstGeom>
+          <a:solidFill>
+            <a:srgbClr val="3A1515"/>
+          </a:solidFill>
+          <a:ln>
+            <a:noFill/>
+          </a:ln>
+        </p:spPr>
+        <p:style>
+          <a:lnRef idx="1">
+            <a:schemeClr val="accent1"/>
+          </a:lnRef>
+          <a:fillRef idx="3">
+            <a:schemeClr val="accent1"/>
+          </a:fillRef>
+          <a:effectRef idx="2">
+            <a:schemeClr val="accent1"/>
+          </a:effectRef>
+          <a:fontRef idx="minor">
+            <a:schemeClr val="lt1"/>
+          </a:fontRef>
+        </p:style>
+        <p:txBody>
+          <a:bodyPr rtlCol="0" anchor="ctr" wrap="square"/>
+          <a:lstStyle/>
+          <a:p>
+            <a:pPr>
+              <a:defRPr sz="900">
+                <a:solidFill>
+                  <a:srgbClr val="CCCCDD"/>
+                </a:solidFill>
+              </a:defRPr>
+            </a:pPr>
+            <a:r>
+              <a:t>🔍 Source Code Investigation Required</a:t>
+            </a:r>
+          </a:p>
+        </p:txBody>
+      </p:sp>
+      <p:sp>
+        <p:nvSpPr>
+          <p:cNvPr id="21" name="Rounded Rectangle 20"/>
+          <p:cNvSpPr/>
+          <p:nvPr/>
+        </p:nvSpPr>
+        <p:spPr>
+          <a:xfrm>
+            <a:off x="6355079" y="2258568"/>
+            <a:ext cx="2103120" cy="384048"/>
+          </a:xfrm>
+          <a:prstGeom prst="roundRect">
+            <a:avLst/>
+          </a:prstGeom>
+          <a:solidFill>
+            <a:srgbClr val="0F2E1A"/>
+          </a:solidFill>
+          <a:ln>
+            <a:noFill/>
+          </a:ln>
+        </p:spPr>
+        <p:style>
+          <a:lnRef idx="1">
+            <a:schemeClr val="accent1"/>
+          </a:lnRef>
+          <a:fillRef idx="3">
+            <a:schemeClr val="accent1"/>
+          </a:fillRef>
+          <a:effectRef idx="2">
+            <a:schemeClr val="accent1"/>
+          </a:effectRef>
+          <a:fontRef idx="minor">
+            <a:schemeClr val="lt1"/>
+          </a:fontRef>
+        </p:style>
+        <p:txBody>
+          <a:bodyPr rtlCol="0" anchor="ctr" wrap="square"/>
+          <a:lstStyle/>
+          <a:p>
+            <a:pPr>
+              <a:defRPr sz="900">
+                <a:solidFill>
+                  <a:srgbClr val="FFFFFF"/>
+                </a:solidFill>
+              </a:defRPr>
+            </a:pPr>
+            <a:r>
+              <a:t>🤖 Automated Analysis</a:t>
+            </a:r>
+          </a:p>
+        </p:txBody>
+      </p:sp>
+      <p:sp>
+        <p:nvSpPr>
+          <p:cNvPr id="22" name="Rounded Rectangle 21"/>
+          <p:cNvSpPr/>
+          <p:nvPr/>
+        </p:nvSpPr>
+        <p:spPr>
+          <a:xfrm>
+            <a:off x="4206240" y="2679191"/>
+            <a:ext cx="2103120" cy="384048"/>
+          </a:xfrm>
+          <a:prstGeom prst="roundRect">
+            <a:avLst/>
+          </a:prstGeom>
+          <a:solidFill>
+            <a:srgbClr val="3A1515"/>
+          </a:solidFill>
+          <a:ln>
+            <a:noFill/>
+          </a:ln>
+        </p:spPr>
+        <p:style>
+          <a:lnRef idx="1">
+            <a:schemeClr val="accent1"/>
+          </a:lnRef>
+          <a:fillRef idx="3">
+            <a:schemeClr val="accent1"/>
+          </a:fillRef>
+          <a:effectRef idx="2">
+            <a:schemeClr val="accent1"/>
+          </a:effectRef>
+          <a:fontRef idx="minor">
+            <a:schemeClr val="lt1"/>
+          </a:fontRef>
+        </p:style>
+        <p:txBody>
+          <a:bodyPr rtlCol="0" anchor="ctr" wrap="square"/>
+          <a:lstStyle/>
+          <a:p>
+            <a:pPr>
+              <a:defRPr sz="900">
+                <a:solidFill>
+                  <a:srgbClr val="CCCCDD"/>
+                </a:solidFill>
+              </a:defRPr>
+            </a:pPr>
+            <a:r>
+              <a:t>🧠 Context Analysis Required</a:t>
+            </a:r>
+          </a:p>
+        </p:txBody>
+      </p:sp>
+      <p:sp>
+        <p:nvSpPr>
+          <p:cNvPr id="23" name="Rounded Rectangle 22"/>
+          <p:cNvSpPr/>
+          <p:nvPr/>
+        </p:nvSpPr>
+        <p:spPr>
+          <a:xfrm>
+            <a:off x="6355079" y="2679191"/>
+            <a:ext cx="2103120" cy="384048"/>
+          </a:xfrm>
+          <a:prstGeom prst="roundRect">
+            <a:avLst/>
+          </a:prstGeom>
+          <a:solidFill>
+            <a:srgbClr val="0F2E1A"/>
+          </a:solidFill>
+          <a:ln>
+            <a:noFill/>
+          </a:ln>
+        </p:spPr>
+        <p:style>
+          <a:lnRef idx="1">
+            <a:schemeClr val="accent1"/>
+          </a:lnRef>
+          <a:fillRef idx="3">
+            <a:schemeClr val="accent1"/>
+          </a:fillRef>
+          <a:effectRef idx="2">
+            <a:schemeClr val="accent1"/>
+          </a:effectRef>
+          <a:fontRef idx="minor">
+            <a:schemeClr val="lt1"/>
+          </a:fontRef>
+        </p:style>
+        <p:txBody>
+          <a:bodyPr rtlCol="0" anchor="ctr" wrap="square"/>
+          <a:lstStyle/>
+          <a:p>
+            <a:pPr>
+              <a:defRPr sz="900">
+                <a:solidFill>
+                  <a:srgbClr val="FFFFFF"/>
+                </a:solidFill>
+              </a:defRPr>
+            </a:pPr>
+            <a:r>
+              <a:t>✅ One Controlled Flow</a:t>
+            </a:r>
+          </a:p>
+        </p:txBody>
+      </p:sp>
+      <p:sp>
+        <p:nvSpPr>
+          <p:cNvPr id="24" name="Rounded Rectangle 23"/>
+          <p:cNvSpPr/>
+          <p:nvPr/>
+        </p:nvSpPr>
+        <p:spPr>
+          <a:xfrm>
+            <a:off x="4206240" y="3099815"/>
+            <a:ext cx="2103120" cy="384048"/>
+          </a:xfrm>
+          <a:prstGeom prst="roundRect">
+            <a:avLst/>
+          </a:prstGeom>
+          <a:solidFill>
+            <a:srgbClr val="3A1515"/>
+          </a:solidFill>
+          <a:ln>
+            <a:noFill/>
+          </a:ln>
+        </p:spPr>
+        <p:style>
+          <a:lnRef idx="1">
+            <a:schemeClr val="accent1"/>
+          </a:lnRef>
+          <a:fillRef idx="3">
+            <a:schemeClr val="accent1"/>
+          </a:fillRef>
+          <a:effectRef idx="2">
+            <a:schemeClr val="accent1"/>
+          </a:effectRef>
+          <a:fontRef idx="minor">
+            <a:schemeClr val="lt1"/>
+          </a:fontRef>
+        </p:style>
+        <p:txBody>
+          <a:bodyPr rtlCol="0" anchor="ctr" wrap="square"/>
+          <a:lstStyle/>
+          <a:p>
+            <a:pPr>
+              <a:defRPr sz="900">
+                <a:solidFill>
+                  <a:srgbClr val="CCCCDD"/>
+                </a:solidFill>
+              </a:defRPr>
+            </a:pPr>
+            <a:r>
+              <a:t>📝 Disposition &amp; Documentation Required</a:t>
+            </a:r>
+          </a:p>
+        </p:txBody>
+      </p:sp>
+      <p:sp>
+        <p:nvSpPr>
+          <p:cNvPr id="25" name="Rounded Rectangle 24"/>
+          <p:cNvSpPr/>
+          <p:nvPr/>
+        </p:nvSpPr>
+        <p:spPr>
+          <a:xfrm>
+            <a:off x="6355079" y="3099815"/>
+            <a:ext cx="2103120" cy="384048"/>
+          </a:xfrm>
+          <a:prstGeom prst="roundRect">
+            <a:avLst/>
+          </a:prstGeom>
+          <a:solidFill>
+            <a:srgbClr val="0F2E1A"/>
+          </a:solidFill>
+          <a:ln>
+            <a:noFill/>
+          </a:ln>
+        </p:spPr>
+        <p:style>
+          <a:lnRef idx="1">
+            <a:schemeClr val="accent1"/>
+          </a:lnRef>
+          <a:fillRef idx="3">
+            <a:schemeClr val="accent1"/>
+          </a:fillRef>
+          <a:effectRef idx="2">
+            <a:schemeClr val="accent1"/>
+          </a:effectRef>
+          <a:fontRef idx="minor">
+            <a:schemeClr val="lt1"/>
+          </a:fontRef>
+        </p:style>
+        <p:txBody>
+          <a:bodyPr rtlCol="0" anchor="ctr" wrap="square"/>
+          <a:lstStyle/>
+          <a:p>
+            <a:pPr>
+              <a:defRPr sz="900">
+                <a:solidFill>
+                  <a:srgbClr val="FFFFFF"/>
+                </a:solidFill>
+              </a:defRPr>
+            </a:pPr>
+            <a:r>
+              <a:t>📊 Higher Quality</a:t>
+            </a:r>
+          </a:p>
+        </p:txBody>
+      </p:sp>
+      <p:sp>
+        <p:nvSpPr>
+          <p:cNvPr id="26" name="TextBox 25"/>
+          <p:cNvSpPr txBox="1"/>
+          <p:nvPr/>
+        </p:nvSpPr>
+        <p:spPr>
+          <a:xfrm>
+            <a:off x="4480559" y="3593591"/>
+            <a:ext cx="2286000" cy="457200"/>
+          </a:xfrm>
+          <a:prstGeom prst="rect">
+            <a:avLst/>
+          </a:prstGeom>
+          <a:noFill/>
+        </p:spPr>
+        <p:txBody>
+          <a:bodyPr wrap="square" anchor="t">
+            <a:spAutoFit/>
+          </a:bodyPr>
+          <a:lstStyle/>
+          <a:p>
+            <a:pPr algn="l">
+              <a:defRPr sz="2800" b="1">
+                <a:solidFill>
+                  <a:srgbClr val="FF6B00"/>
+                </a:solidFill>
+                <a:latin typeface="Calibri"/>
+              </a:defRPr>
+            </a:pPr>
+            <a:r>
+              <a:t>~90%</a:t>
+            </a:r>
+          </a:p>
+        </p:txBody>
+      </p:sp>
+      <p:sp>
+        <p:nvSpPr>
+          <p:cNvPr id="27" name="TextBox 26"/>
+          <p:cNvSpPr txBox="1"/>
+          <p:nvPr/>
+        </p:nvSpPr>
+        <p:spPr>
+          <a:xfrm>
+            <a:off x="4480559" y="3941063"/>
+            <a:ext cx="2286000" cy="274320"/>
+          </a:xfrm>
+          <a:prstGeom prst="rect">
+            <a:avLst/>
+          </a:prstGeom>
+          <a:noFill/>
+        </p:spPr>
+        <p:txBody>
+          <a:bodyPr wrap="square" anchor="t">
+            <a:spAutoFit/>
+          </a:bodyPr>
+          <a:lstStyle/>
+          <a:p>
+            <a:pPr algn="l">
+              <a:defRPr sz="1100" b="0">
+                <a:solidFill>
+                  <a:srgbClr val="CCCCDD"/>
+                </a:solidFill>
+                <a:latin typeface="Calibri"/>
+              </a:defRPr>
+            </a:pPr>
+            <a:r>
+              <a:t>Time Reduction</a:t>
+            </a:r>
+          </a:p>
+        </p:txBody>
+      </p:sp>
+      <p:sp>
+        <p:nvSpPr>
+          <p:cNvPr id="28" name="TextBox 27"/>
+          <p:cNvSpPr txBox="1"/>
+          <p:nvPr/>
+        </p:nvSpPr>
+        <p:spPr>
+          <a:xfrm>
+            <a:off x="365760" y="4434840"/>
+            <a:ext cx="4114800" cy="320040"/>
+          </a:xfrm>
+          <a:prstGeom prst="rect">
+            <a:avLst/>
+          </a:prstGeom>
+          <a:noFill/>
+        </p:spPr>
+        <p:txBody>
+          <a:bodyPr wrap="square" anchor="t">
+            <a:spAutoFit/>
+          </a:bodyPr>
+          <a:lstStyle/>
+          <a:p>
+            <a:pPr algn="l">
+              <a:defRPr sz="1400" b="1">
+                <a:solidFill>
+                  <a:srgbClr val="FF6B00"/>
+                </a:solidFill>
+                <a:latin typeface="Calibri"/>
+              </a:defRPr>
+            </a:pPr>
+            <a:r>
+              <a:t>💰  COST SAVINGS PER PROGRAM</a:t>
+            </a:r>
+          </a:p>
+        </p:txBody>
+      </p:sp>
+      <p:sp>
+        <p:nvSpPr>
+          <p:cNvPr id="29" name="TextBox 28"/>
+          <p:cNvSpPr txBox="1"/>
+          <p:nvPr/>
+        </p:nvSpPr>
+        <p:spPr>
+          <a:xfrm>
+            <a:off x="457200" y="4754879"/>
+            <a:ext cx="5943600" cy="256032"/>
+          </a:xfrm>
+          <a:prstGeom prst="rect">
+            <a:avLst/>
+          </a:prstGeom>
+          <a:noFill/>
+        </p:spPr>
+        <p:txBody>
+          <a:bodyPr wrap="square" anchor="t">
+            <a:spAutoFit/>
+          </a:bodyPr>
+          <a:lstStyle/>
+          <a:p>
+            <a:pPr algn="l">
+              <a:defRPr sz="1200" b="0">
+                <a:solidFill>
+                  <a:srgbClr val="FFFFFF"/>
+                </a:solidFill>
+                <a:latin typeface="Calibri"/>
+              </a:defRPr>
+            </a:pPr>
+            <a:r>
+              <a:t>RL1 (1,000 defects): 250 hrs → 33 hrs = </a:t>
+            </a:r>
+          </a:p>
+        </p:txBody>
+      </p:sp>
+      <p:sp>
+        <p:nvSpPr>
+          <p:cNvPr id="30" name="TextBox 29"/>
+          <p:cNvSpPr txBox="1"/>
+          <p:nvPr/>
+        </p:nvSpPr>
+        <p:spPr>
+          <a:xfrm>
+            <a:off x="4572000" y="4754879"/>
+            <a:ext cx="2743200" cy="256032"/>
+          </a:xfrm>
+          <a:prstGeom prst="rect">
+            <a:avLst/>
+          </a:prstGeom>
+          <a:noFill/>
+        </p:spPr>
+        <p:txBody>
+          <a:bodyPr wrap="square" anchor="t">
+            <a:spAutoFit/>
+          </a:bodyPr>
+          <a:lstStyle/>
+          <a:p>
+            <a:pPr algn="l">
+              <a:defRPr sz="1200" b="1">
+                <a:solidFill>
+                  <a:srgbClr val="FF6B00"/>
+                </a:solidFill>
+                <a:latin typeface="Calibri"/>
+              </a:defRPr>
+            </a:pPr>
+            <a:r>
+              <a:t>217 hrs SAVED</a:t>
+            </a:r>
+          </a:p>
+        </p:txBody>
+      </p:sp>
+      <p:sp>
+        <p:nvSpPr>
+          <p:cNvPr id="31" name="TextBox 30"/>
+          <p:cNvSpPr txBox="1"/>
+          <p:nvPr/>
+        </p:nvSpPr>
+        <p:spPr>
+          <a:xfrm>
+            <a:off x="457200" y="5029199"/>
+            <a:ext cx="5943600" cy="256032"/>
+          </a:xfrm>
+          <a:prstGeom prst="rect">
+            <a:avLst/>
+          </a:prstGeom>
+          <a:noFill/>
+        </p:spPr>
+        <p:txBody>
+          <a:bodyPr wrap="square" anchor="t">
+            <a:spAutoFit/>
+          </a:bodyPr>
+          <a:lstStyle/>
+          <a:p>
+            <a:pPr algn="l">
+              <a:defRPr sz="1200" b="0">
+                <a:solidFill>
+                  <a:srgbClr val="FFFFFF"/>
+                </a:solidFill>
+                <a:latin typeface="Calibri"/>
+              </a:defRPr>
+            </a:pPr>
+            <a:r>
+              <a:t>Program (4,000 defects): 1,000 hrs → 133 hrs = </a:t>
+            </a:r>
+          </a:p>
+        </p:txBody>
+      </p:sp>
+      <p:sp>
+        <p:nvSpPr>
+          <p:cNvPr id="32" name="TextBox 31"/>
+          <p:cNvSpPr txBox="1"/>
+          <p:nvPr/>
+        </p:nvSpPr>
+        <p:spPr>
+          <a:xfrm>
+            <a:off x="4572000" y="5029199"/>
+            <a:ext cx="2743200" cy="256032"/>
+          </a:xfrm>
+          <a:prstGeom prst="rect">
+            <a:avLst/>
+          </a:prstGeom>
+          <a:noFill/>
+        </p:spPr>
+        <p:txBody>
+          <a:bodyPr wrap="square" anchor="t">
+            <a:spAutoFit/>
+          </a:bodyPr>
+          <a:lstStyle/>
+          <a:p>
+            <a:pPr algn="l">
+              <a:defRPr sz="1200" b="1">
+                <a:solidFill>
+                  <a:srgbClr val="FF6B00"/>
+                </a:solidFill>
+                <a:latin typeface="Calibri"/>
+              </a:defRPr>
+            </a:pPr>
+            <a:r>
+              <a:t>867 hrs SAVED</a:t>
+            </a:r>
+          </a:p>
+        </p:txBody>
+      </p:sp>
+      <p:sp>
+        <p:nvSpPr>
+          <p:cNvPr id="33" name="TextBox 32"/>
+          <p:cNvSpPr txBox="1"/>
+          <p:nvPr/>
+        </p:nvSpPr>
+        <p:spPr>
+          <a:xfrm>
+            <a:off x="457200" y="5321807"/>
+            <a:ext cx="5943600" cy="256032"/>
+          </a:xfrm>
+          <a:prstGeom prst="rect">
+            <a:avLst/>
+          </a:prstGeom>
+          <a:noFill/>
+        </p:spPr>
+        <p:txBody>
+          <a:bodyPr wrap="square" anchor="t">
+            <a:spAutoFit/>
+          </a:bodyPr>
+          <a:lstStyle/>
+          <a:p>
+            <a:pPr algn="l">
+              <a:defRPr sz="1200" b="1">
+                <a:solidFill>
+                  <a:srgbClr val="FFCC00"/>
+                </a:solidFill>
+                <a:latin typeface="Calibri"/>
+              </a:defRPr>
+            </a:pPr>
+            <a:r>
+              <a:t>RL1: $7,595  |  Program: $30,345  per release (at $35/hr)</a:t>
+            </a:r>
+          </a:p>
+        </p:txBody>
+      </p:sp>
+      <p:sp>
+        <p:nvSpPr>
+          <p:cNvPr id="34" name="Rounded Rectangle 33"/>
+          <p:cNvSpPr/>
+          <p:nvPr/>
+        </p:nvSpPr>
+        <p:spPr>
+          <a:xfrm>
+            <a:off x="7498079" y="1280160"/>
+            <a:ext cx="1463040" cy="1097280"/>
+          </a:xfrm>
+          <a:prstGeom prst="roundRect">
+            <a:avLst/>
+          </a:prstGeom>
+          <a:solidFill>
+            <a:srgbClr val="11182E"/>
+          </a:solidFill>
+          <a:ln w="19050">
+            <a:solidFill>
+              <a:srgbClr val="00CCFF"/>
+            </a:solidFill>
+          </a:ln>
+        </p:spPr>
+        <p:style>
+          <a:lnRef idx="1">
+            <a:schemeClr val="accent1"/>
+          </a:lnRef>
+          <a:fillRef idx="3">
+            <a:schemeClr val="accent1"/>
+          </a:fillRef>
+          <a:effectRef idx="2">
+            <a:schemeClr val="accent1"/>
+          </a:effectRef>
+          <a:fontRef idx="minor">
+            <a:schemeClr val="lt1"/>
+          </a:fontRef>
+        </p:style>
+        <p:txBody>
+          <a:bodyPr rtlCol="0" anchor="ctr"/>
+          <a:lstStyle/>
+          <a:p>
+            <a:pPr algn="ctr">
+              <a:defRPr sz="2200"/>
+            </a:pPr>
+            <a:r>
+              <a:t>📄</a:t>
+            </a:r>
+          </a:p>
+          <a:p>
+            <a:pPr algn="ctr">
+              <a:defRPr sz="1000">
+                <a:solidFill>
+                  <a:srgbClr val="FFFFFF"/>
+                </a:solidFill>
+              </a:defRPr>
+            </a:pPr>
+            <a:r>
+              <a:t>Coverity</a:t>
+            </a:r>
+          </a:p>
+          <a:p>
+            <a:pPr algn="ctr">
+              <a:defRPr sz="1000">
+                <a:solidFill>
+                  <a:srgbClr val="FFFFFF"/>
+                </a:solidFill>
+              </a:defRPr>
+            </a:pPr>
+            <a:r>
+              <a:t>report</a:t>
+            </a:r>
+          </a:p>
+        </p:txBody>
+      </p:sp>
+      <p:sp>
+        <p:nvSpPr>
+          <p:cNvPr id="35" name="TextBox 34"/>
+          <p:cNvSpPr txBox="1"/>
+          <p:nvPr/>
+        </p:nvSpPr>
+        <p:spPr>
+          <a:xfrm>
+            <a:off x="7498079" y="1051560"/>
+            <a:ext cx="1463040" cy="228600"/>
+          </a:xfrm>
+          <a:prstGeom prst="rect">
+            <a:avLst/>
+          </a:prstGeom>
+          <a:noFill/>
+        </p:spPr>
+        <p:txBody>
+          <a:bodyPr wrap="square" anchor="t">
+            <a:spAutoFit/>
+          </a:bodyPr>
+          <a:lstStyle/>
+          <a:p>
+            <a:pPr algn="ctr">
+              <a:defRPr sz="900" b="0">
+                <a:solidFill>
+                  <a:srgbClr val="CCCCDD"/>
+                </a:solidFill>
+                <a:latin typeface="Calibri"/>
+              </a:defRPr>
+            </a:pPr>
+            <a:r>
+              <a:t>Input</a:t>
+            </a:r>
+          </a:p>
+        </p:txBody>
+      </p:sp>
+      <p:sp>
+        <p:nvSpPr>
+          <p:cNvPr id="36" name="Right Arrow 35"/>
+          <p:cNvSpPr/>
+          <p:nvPr/>
+        </p:nvSpPr>
+        <p:spPr>
+          <a:xfrm>
+            <a:off x="8869680" y="1691640"/>
+            <a:ext cx="640080" cy="274320"/>
+          </a:xfrm>
+          <a:prstGeom prst="rightArrow">
+            <a:avLst/>
+          </a:prstGeom>
+          <a:solidFill>
+            <a:srgbClr val="FF6B00"/>
+          </a:solidFill>
+          <a:ln>
+            <a:noFill/>
+          </a:ln>
+        </p:spPr>
+        <p:style>
+          <a:lnRef idx="1">
+            <a:schemeClr val="accent1"/>
+          </a:lnRef>
+          <a:fillRef idx="3">
+            <a:schemeClr val="accent1"/>
+          </a:fillRef>
+          <a:effectRef idx="2">
+            <a:schemeClr val="accent1"/>
+          </a:effectRef>
+          <a:fontRef idx="minor">
+            <a:schemeClr val="lt1"/>
+          </a:fontRef>
+        </p:style>
+        <p:txBody>
+          <a:bodyPr rtlCol="0" anchor="ctr"/>
+          <a:lstStyle/>
+          <a:p>
+            <a:pPr algn="ctr"/>
+          </a:p>
+        </p:txBody>
+      </p:sp>
+      <p:sp>
+        <p:nvSpPr>
+          <p:cNvPr id="37" name="Rounded Rectangle 36"/>
+          <p:cNvSpPr/>
+          <p:nvPr/>
+        </p:nvSpPr>
+        <p:spPr>
+          <a:xfrm>
+            <a:off x="9418319" y="1280160"/>
+            <a:ext cx="1828800" cy="1097280"/>
+          </a:xfrm>
+          <a:prstGeom prst="roundRect">
+            <a:avLst/>
+          </a:prstGeom>
+          <a:solidFill>
+            <a:srgbClr val="11182E"/>
+          </a:solidFill>
+          <a:ln w="19050">
+            <a:solidFill>
+              <a:srgbClr val="00CCFF"/>
+            </a:solidFill>
+          </a:ln>
+        </p:spPr>
+        <p:style>
+          <a:lnRef idx="1">
+            <a:schemeClr val="accent1"/>
+          </a:lnRef>
+          <a:fillRef idx="3">
+            <a:schemeClr val="accent1"/>
+          </a:fillRef>
+          <a:effectRef idx="2">
+            <a:schemeClr val="accent1"/>
+          </a:effectRef>
+          <a:fontRef idx="minor">
+            <a:schemeClr val="lt1"/>
+          </a:fontRef>
+        </p:style>
+        <p:txBody>
+          <a:bodyPr rtlCol="0" anchor="ctr"/>
+          <a:lstStyle/>
+          <a:p>
+            <a:pPr algn="ctr">
               <a:defRPr sz="2000"/>
             </a:pPr>
             <a:r>
-              <a:t>AI-Developed, Rule-Based Static Analysis for Aerospace</a:t>
-            </a:r>
-          </a:p>
-          <a:p>
-            <a:r>
-              <a:t>CNS AI Day 2026 | Rakesh Boya | Honeywell Aerospace | Confidential</a:t>
-            </a:r>
-          </a:p>
-        </p:txBody>
-      </p:sp>
-    </p:spTree>
-  </p:cSld>
-  <p:clrMapOvr>
-    <a:masterClrMapping/>
-  </p:clrMapOvr>
-</p:sld>
-</file>
-
-<file path=ppt/slides/slide2.xml><?xml version="1.0" encoding="utf-8"?>
-<p:sld xmlns:a="http://schemas.openxmlformats.org/drawingml/2006/main" xmlns:p="http://schemas.openxmlformats.org/presentationml/2006/main" xmlns:r="http://schemas.openxmlformats.org/officeDocument/2006/relationships">
-  <p:cSld>
-    <p:spTree>
-      <p:nvGrpSpPr>
-        <p:cNvPr id="1" name=""/>
-        <p:cNvGrpSpPr/>
-        <p:nvPr/>
-      </p:nvGrpSpPr>
-      <p:grpSpPr/>
-      <p:sp>
-        <p:nvSpPr>
-          <p:cNvPr id="2" name="Title 1"/>
-          <p:cNvSpPr>
-            <a:spLocks noGrp="1"/>
-          </p:cNvSpPr>
-          <p:nvPr>
-            <p:ph type="title"/>
-          </p:nvPr>
-        </p:nvSpPr>
-        <p:spPr/>
-        <p:txBody>
-          <a:bodyPr/>
-          <a:lstStyle/>
-          <a:p>
-            <a:pPr>
-              <a:defRPr b="1" sz="3600"/>
+              <a:t>🌳</a:t>
+            </a:r>
+          </a:p>
+          <a:p>
+            <a:pPr algn="ctr">
+              <a:defRPr sz="1000">
+                <a:solidFill>
+                  <a:srgbClr val="00CCFF"/>
+                </a:solidFill>
+              </a:defRPr>
             </a:pPr>
             <a:r>
-              <a:t>Key Features &amp; Impact</a:t>
-            </a:r>
-          </a:p>
-        </p:txBody>
-      </p:sp>
-      <p:sp>
-        <p:nvSpPr>
-          <p:cNvPr id="3" name="Content Placeholder 2"/>
-          <p:cNvSpPr>
-            <a:spLocks noGrp="1"/>
-          </p:cNvSpPr>
-          <p:nvPr>
-            <p:ph idx="1"/>
-          </p:nvPr>
-        </p:nvSpPr>
-        <p:spPr/>
-        <p:txBody>
-          <a:bodyPr/>
-          <a:lstStyle/>
-          <a:p>
-            <a:r>
-              <a:t>🎯 CORE FEATURES</a:t>
-            </a:r>
-          </a:p>
-          <a:p>
-            <a:r>
-              <a:t>• Aerospace Compliance: DO-178C, MISRA, CERT</a:t>
-            </a:r>
-          </a:p>
-          <a:p>
-            <a:r>
-              <a:t>• 100% Secure &amp; Offline: Source never leaves machine</a:t>
-            </a:r>
-          </a:p>
-          <a:p>
-            <a:r>
-              <a:t>• No AI Tokens Required: Runs 100% offline</a:t>
-            </a:r>
-          </a:p>
-          <a:p>
-            <a:r>
-              <a:t>• Reduces SME Dependency: 80% reduction</a:t>
-            </a:r>
-          </a:p>
-          <a:p/>
-          <a:p>
-            <a:r>
-              <a:t>⚖️ MANUAL vs AUTOMATED</a:t>
-            </a:r>
-          </a:p>
-          <a:p>
-            <a:r>
-              <a:t>👨‍💻 MANUAL: ⏱️ 10-15 min/defect, 🔍 Investigation, 📝 Documentation</a:t>
-            </a:r>
-          </a:p>
-          <a:p>
-            <a:r>
-              <a:t>🤖 AUTOMATED: ⚡ 1-2 min/defect, 🎯 Automated, 🔄 Controlled Flow</a:t>
-            </a:r>
-          </a:p>
-          <a:p>
-            <a:r>
-              <a:t>~90% Time Reduction</a:t>
-            </a:r>
-          </a:p>
-          <a:p/>
-          <a:p>
-            <a:r>
-              <a:t>💰 COST SAVINGS PER PROGRAM:</a:t>
-            </a:r>
-          </a:p>
-          <a:p>
-            <a:r>
-              <a:t>• RL1: 217 hrs SAVED</a:t>
-            </a:r>
-          </a:p>
-          <a:p>
-            <a:r>
-              <a:t>• Program: 867 hrs SAVED</a:t>
-            </a:r>
-          </a:p>
-          <a:p>
-            <a:r>
-              <a:t>• Cost: $7,595-$30,345 per release</a:t>
+              <a:t>Tree-sitter</a:t>
+            </a:r>
+          </a:p>
+        </p:txBody>
+      </p:sp>
+      <p:sp>
+        <p:nvSpPr>
+          <p:cNvPr id="38" name="TextBox 37"/>
+          <p:cNvSpPr txBox="1"/>
+          <p:nvPr/>
+        </p:nvSpPr>
+        <p:spPr>
+          <a:xfrm>
+            <a:off x="9143999" y="914400"/>
+            <a:ext cx="2377440" cy="182880"/>
+          </a:xfrm>
+          <a:prstGeom prst="rect">
+            <a:avLst/>
+          </a:prstGeom>
+          <a:noFill/>
+        </p:spPr>
+        <p:txBody>
+          <a:bodyPr wrap="square" anchor="t">
+            <a:spAutoFit/>
+          </a:bodyPr>
+          <a:lstStyle/>
+          <a:p>
+            <a:pPr algn="ctr">
+              <a:defRPr sz="900" b="0">
+                <a:solidFill>
+                  <a:srgbClr val="CCCCDD"/>
+                </a:solidFill>
+                <a:latin typeface="Calibri"/>
+              </a:defRPr>
+            </a:pPr>
+            <a:r>
+              <a:t>Processing Stage 1</a:t>
+            </a:r>
+          </a:p>
+        </p:txBody>
+      </p:sp>
+      <p:sp>
+        <p:nvSpPr>
+          <p:cNvPr id="39" name="TextBox 38"/>
+          <p:cNvSpPr txBox="1"/>
+          <p:nvPr/>
+        </p:nvSpPr>
+        <p:spPr>
+          <a:xfrm>
+            <a:off x="9143999" y="1051560"/>
+            <a:ext cx="2377440" cy="274320"/>
+          </a:xfrm>
+          <a:prstGeom prst="rect">
+            <a:avLst/>
+          </a:prstGeom>
+          <a:noFill/>
+        </p:spPr>
+        <p:txBody>
+          <a:bodyPr wrap="square" anchor="t">
+            <a:spAutoFit/>
+          </a:bodyPr>
+          <a:lstStyle/>
+          <a:p>
+            <a:pPr algn="ctr">
+              <a:defRPr sz="1200" b="1">
+                <a:solidFill>
+                  <a:srgbClr val="FFFFFF"/>
+                </a:solidFill>
+                <a:latin typeface="Calibri"/>
+              </a:defRPr>
+            </a:pPr>
+            <a:r>
+              <a:t>Source Parser</a:t>
+            </a:r>
+          </a:p>
+        </p:txBody>
+      </p:sp>
+      <p:sp>
+        <p:nvSpPr>
+          <p:cNvPr id="40" name="Down Arrow 39"/>
+          <p:cNvSpPr/>
+          <p:nvPr/>
+        </p:nvSpPr>
+        <p:spPr>
+          <a:xfrm>
+            <a:off x="10241280" y="2331720"/>
+            <a:ext cx="274320" cy="457200"/>
+          </a:xfrm>
+          <a:prstGeom prst="downArrow">
+            <a:avLst/>
+          </a:prstGeom>
+          <a:solidFill>
+            <a:srgbClr val="FF6B00"/>
+          </a:solidFill>
+          <a:ln>
+            <a:noFill/>
+          </a:ln>
+        </p:spPr>
+        <p:style>
+          <a:lnRef idx="1">
+            <a:schemeClr val="accent1"/>
+          </a:lnRef>
+          <a:fillRef idx="3">
+            <a:schemeClr val="accent1"/>
+          </a:fillRef>
+          <a:effectRef idx="2">
+            <a:schemeClr val="accent1"/>
+          </a:effectRef>
+          <a:fontRef idx="minor">
+            <a:schemeClr val="lt1"/>
+          </a:fontRef>
+        </p:style>
+        <p:txBody>
+          <a:bodyPr rtlCol="0" anchor="ctr"/>
+          <a:lstStyle/>
+          <a:p>
+            <a:pPr algn="ctr"/>
+          </a:p>
+        </p:txBody>
+      </p:sp>
+      <p:sp>
+        <p:nvSpPr>
+          <p:cNvPr id="41" name="Rounded Rectangle 40"/>
+          <p:cNvSpPr/>
+          <p:nvPr/>
+        </p:nvSpPr>
+        <p:spPr>
+          <a:xfrm>
+            <a:off x="9418319" y="2743200"/>
+            <a:ext cx="2194560" cy="1097280"/>
+          </a:xfrm>
+          <a:prstGeom prst="roundRect">
+            <a:avLst/>
+          </a:prstGeom>
+          <a:solidFill>
+            <a:srgbClr val="11182E"/>
+          </a:solidFill>
+          <a:ln w="19050">
+            <a:solidFill>
+              <a:srgbClr val="FF6B00"/>
+            </a:solidFill>
+          </a:ln>
+        </p:spPr>
+        <p:style>
+          <a:lnRef idx="1">
+            <a:schemeClr val="accent1"/>
+          </a:lnRef>
+          <a:fillRef idx="3">
+            <a:schemeClr val="accent1"/>
+          </a:fillRef>
+          <a:effectRef idx="2">
+            <a:schemeClr val="accent1"/>
+          </a:effectRef>
+          <a:fontRef idx="minor">
+            <a:schemeClr val="lt1"/>
+          </a:fontRef>
+        </p:style>
+        <p:txBody>
+          <a:bodyPr rtlCol="0" anchor="ctr"/>
+          <a:lstStyle/>
+          <a:p>
+            <a:pPr algn="ctr">
+              <a:defRPr sz="2000"/>
+            </a:pPr>
+            <a:r>
+              <a:t>⚙️</a:t>
+            </a:r>
+          </a:p>
+          <a:p>
+            <a:pPr algn="ctr">
+              <a:defRPr sz="1200" b="1">
+                <a:solidFill>
+                  <a:srgbClr val="FF6B00"/>
+                </a:solidFill>
+              </a:defRPr>
+            </a:pPr>
+            <a:r>
+              <a:t>Rule Engine</a:t>
+            </a:r>
+          </a:p>
+          <a:p>
+            <a:pPr algn="ctr">
+              <a:defRPr sz="900">
+                <a:solidFill>
+                  <a:srgbClr val="CCCCDD"/>
+                </a:solidFill>
+              </a:defRPr>
+            </a:pPr>
+            <a:r>
+              <a:t>20+ Checker Rules</a:t>
+            </a:r>
+          </a:p>
+        </p:txBody>
+      </p:sp>
+      <p:sp>
+        <p:nvSpPr>
+          <p:cNvPr id="42" name="TextBox 41"/>
+          <p:cNvSpPr txBox="1"/>
+          <p:nvPr/>
+        </p:nvSpPr>
+        <p:spPr>
+          <a:xfrm>
+            <a:off x="9143999" y="2468880"/>
+            <a:ext cx="2743200" cy="228600"/>
+          </a:xfrm>
+          <a:prstGeom prst="rect">
+            <a:avLst/>
+          </a:prstGeom>
+          <a:noFill/>
+        </p:spPr>
+        <p:txBody>
+          <a:bodyPr wrap="square" anchor="t">
+            <a:spAutoFit/>
+          </a:bodyPr>
+          <a:lstStyle/>
+          <a:p>
+            <a:pPr algn="ctr">
+              <a:defRPr sz="900" b="0">
+                <a:solidFill>
+                  <a:srgbClr val="CCCCDD"/>
+                </a:solidFill>
+                <a:latin typeface="Calibri"/>
+              </a:defRPr>
+            </a:pPr>
+            <a:r>
+              <a:t>Processing Stage 2</a:t>
+            </a:r>
+          </a:p>
+        </p:txBody>
+      </p:sp>
+      <p:sp>
+        <p:nvSpPr>
+          <p:cNvPr id="43" name="Down Arrow 42"/>
+          <p:cNvSpPr/>
+          <p:nvPr/>
+        </p:nvSpPr>
+        <p:spPr>
+          <a:xfrm>
+            <a:off x="10332719" y="3840480"/>
+            <a:ext cx="320040" cy="457200"/>
+          </a:xfrm>
+          <a:prstGeom prst="downArrow">
+            <a:avLst/>
+          </a:prstGeom>
+          <a:solidFill>
+            <a:srgbClr val="FF6B00"/>
+          </a:solidFill>
+          <a:ln>
+            <a:noFill/>
+          </a:ln>
+        </p:spPr>
+        <p:style>
+          <a:lnRef idx="1">
+            <a:schemeClr val="accent1"/>
+          </a:lnRef>
+          <a:fillRef idx="3">
+            <a:schemeClr val="accent1"/>
+          </a:fillRef>
+          <a:effectRef idx="2">
+            <a:schemeClr val="accent1"/>
+          </a:effectRef>
+          <a:fontRef idx="minor">
+            <a:schemeClr val="lt1"/>
+          </a:fontRef>
+        </p:style>
+        <p:txBody>
+          <a:bodyPr rtlCol="0" anchor="ctr"/>
+          <a:lstStyle/>
+          <a:p>
+            <a:pPr algn="ctr"/>
+          </a:p>
+        </p:txBody>
+      </p:sp>
+      <p:sp>
+        <p:nvSpPr>
+          <p:cNvPr id="44" name="Rounded Rectangle 43"/>
+          <p:cNvSpPr/>
+          <p:nvPr/>
+        </p:nvSpPr>
+        <p:spPr>
+          <a:xfrm>
+            <a:off x="9601200" y="4389120"/>
+            <a:ext cx="1828800" cy="1097280"/>
+          </a:xfrm>
+          <a:prstGeom prst="roundRect">
+            <a:avLst/>
+          </a:prstGeom>
+          <a:solidFill>
+            <a:srgbClr val="11182E"/>
+          </a:solidFill>
+          <a:ln w="19050">
+            <a:solidFill>
+              <a:srgbClr val="00CC66"/>
+            </a:solidFill>
+          </a:ln>
+        </p:spPr>
+        <p:style>
+          <a:lnRef idx="1">
+            <a:schemeClr val="accent1"/>
+          </a:lnRef>
+          <a:fillRef idx="3">
+            <a:schemeClr val="accent1"/>
+          </a:fillRef>
+          <a:effectRef idx="2">
+            <a:schemeClr val="accent1"/>
+          </a:effectRef>
+          <a:fontRef idx="minor">
+            <a:schemeClr val="lt1"/>
+          </a:fontRef>
+        </p:style>
+        <p:txBody>
+          <a:bodyPr rtlCol="0" anchor="ctr"/>
+          <a:lstStyle/>
+          <a:p>
+            <a:pPr algn="ctr">
+              <a:defRPr sz="2200"/>
+            </a:pPr>
+            <a:r>
+              <a:t>✅</a:t>
+            </a:r>
+          </a:p>
+          <a:p>
+            <a:pPr algn="ctr">
+              <a:defRPr sz="1100" b="1">
+                <a:solidFill>
+                  <a:srgbClr val="00CC66"/>
+                </a:solidFill>
+              </a:defRPr>
+            </a:pPr>
+            <a:r>
+              <a:t>Smart</a:t>
+            </a:r>
+          </a:p>
+          <a:p>
+            <a:pPr algn="ctr">
+              <a:defRPr sz="1100">
+                <a:solidFill>
+                  <a:srgbClr val="00CC66"/>
+                </a:solidFill>
+              </a:defRPr>
+            </a:pPr>
+            <a:r>
+              <a:t>Dispositions</a:t>
+            </a:r>
+          </a:p>
+        </p:txBody>
+      </p:sp>
+      <p:sp>
+        <p:nvSpPr>
+          <p:cNvPr id="45" name="TextBox 44"/>
+          <p:cNvSpPr txBox="1"/>
+          <p:nvPr/>
+        </p:nvSpPr>
+        <p:spPr>
+          <a:xfrm>
+            <a:off x="7040879" y="5669280"/>
+            <a:ext cx="5029200" cy="274320"/>
+          </a:xfrm>
+          <a:prstGeom prst="rect">
+            <a:avLst/>
+          </a:prstGeom>
+          <a:noFill/>
+        </p:spPr>
+        <p:txBody>
+          <a:bodyPr wrap="square" anchor="t">
+            <a:spAutoFit/>
+          </a:bodyPr>
+          <a:lstStyle/>
+          <a:p>
+            <a:pPr algn="ctr">
+              <a:defRPr sz="1300" b="1">
+                <a:solidFill>
+                  <a:srgbClr val="CCCCDD"/>
+                </a:solidFill>
+                <a:latin typeface="Calibri"/>
+              </a:defRPr>
+            </a:pPr>
+            <a:r>
+              <a:t>AI used to DEVELOP, analysis is RULE-BASED</a:t>
             </a:r>
           </a:p>
         </p:txBody>

</xml_diff>

<commit_message>
Update Coverity slide: add savings figures, real saving case study, and future targeted programs
Co-authored-by: arena-agent <297053741+arena-agent@users.noreply.github.com>
</commit_message>
<xml_diff>
--- a/Coverity_Findings_Analyzer.pptx
+++ b/Coverity_Findings_Analyzer.pptx
@@ -4254,8 +4254,8 @@
         </p:nvSpPr>
         <p:spPr>
           <a:xfrm>
-            <a:off x="457200" y="4754879"/>
-            <a:ext cx="5943600" cy="256032"/>
+            <a:off x="457200" y="4727448"/>
+            <a:ext cx="4389120" cy="228600"/>
           </a:xfrm>
           <a:prstGeom prst="rect">
             <a:avLst/>
@@ -4269,7 +4269,7 @@
           <a:lstStyle/>
           <a:p>
             <a:pPr algn="l">
-              <a:defRPr sz="1200" b="0">
+              <a:defRPr sz="1100" b="0">
                 <a:solidFill>
                   <a:srgbClr val="FFFFFF"/>
                 </a:solidFill>
@@ -4290,8 +4290,8 @@
         </p:nvSpPr>
         <p:spPr>
           <a:xfrm>
-            <a:off x="4572000" y="4754879"/>
-            <a:ext cx="2743200" cy="256032"/>
+            <a:off x="4023360" y="4727448"/>
+            <a:ext cx="1645920" cy="228600"/>
           </a:xfrm>
           <a:prstGeom prst="rect">
             <a:avLst/>
@@ -4305,7 +4305,7 @@
           <a:lstStyle/>
           <a:p>
             <a:pPr algn="l">
-              <a:defRPr sz="1200" b="1">
+              <a:defRPr sz="1100" b="1">
                 <a:solidFill>
                   <a:srgbClr val="FF6B00"/>
                 </a:solidFill>
@@ -4313,7 +4313,7 @@
               </a:defRPr>
             </a:pPr>
             <a:r>
-              <a:t>217 hrs SAVED</a:t>
+              <a:t>217 hrs SAVED </a:t>
             </a:r>
           </a:p>
         </p:txBody>
@@ -4326,8 +4326,8 @@
         </p:nvSpPr>
         <p:spPr>
           <a:xfrm>
-            <a:off x="457200" y="5029199"/>
-            <a:ext cx="5943600" cy="256032"/>
+            <a:off x="5120640" y="4727448"/>
+            <a:ext cx="1371600" cy="228600"/>
           </a:xfrm>
           <a:prstGeom prst="rect">
             <a:avLst/>
@@ -4341,15 +4341,15 @@
           <a:lstStyle/>
           <a:p>
             <a:pPr algn="l">
-              <a:defRPr sz="1200" b="0">
-                <a:solidFill>
-                  <a:srgbClr val="FFFFFF"/>
+              <a:defRPr sz="1100" b="1">
+                <a:solidFill>
+                  <a:srgbClr val="FFCC00"/>
                 </a:solidFill>
                 <a:latin typeface="Calibri"/>
               </a:defRPr>
             </a:pPr>
             <a:r>
-              <a:t>Program (4,000 defects): 1,000 hrs → 133 hrs = </a:t>
+              <a:t>*($7k)*</a:t>
             </a:r>
           </a:p>
         </p:txBody>
@@ -4362,8 +4362,8 @@
         </p:nvSpPr>
         <p:spPr>
           <a:xfrm>
-            <a:off x="4572000" y="5029199"/>
-            <a:ext cx="2743200" cy="256032"/>
+            <a:off x="457200" y="4956048"/>
+            <a:ext cx="4389120" cy="228600"/>
           </a:xfrm>
           <a:prstGeom prst="rect">
             <a:avLst/>
@@ -4377,15 +4377,15 @@
           <a:lstStyle/>
           <a:p>
             <a:pPr algn="l">
-              <a:defRPr sz="1200" b="1">
-                <a:solidFill>
-                  <a:srgbClr val="FF6B00"/>
+              <a:defRPr sz="1100" b="0">
+                <a:solidFill>
+                  <a:srgbClr val="FFFFFF"/>
                 </a:solidFill>
                 <a:latin typeface="Calibri"/>
               </a:defRPr>
             </a:pPr>
             <a:r>
-              <a:t>867 hrs SAVED</a:t>
+              <a:t>Program (4,000 defects): 1,000 hrs → 133 hrs = </a:t>
             </a:r>
           </a:p>
         </p:txBody>
@@ -4398,8 +4398,8 @@
         </p:nvSpPr>
         <p:spPr>
           <a:xfrm>
-            <a:off x="457200" y="5321807"/>
-            <a:ext cx="5943600" cy="256032"/>
+            <a:off x="4023360" y="4956048"/>
+            <a:ext cx="1645920" cy="228600"/>
           </a:xfrm>
           <a:prstGeom prst="rect">
             <a:avLst/>
@@ -4413,22 +4413,238 @@
           <a:lstStyle/>
           <a:p>
             <a:pPr algn="l">
+              <a:defRPr sz="1100" b="1">
+                <a:solidFill>
+                  <a:srgbClr val="FF6B00"/>
+                </a:solidFill>
+                <a:latin typeface="Calibri"/>
+              </a:defRPr>
+            </a:pPr>
+            <a:r>
+              <a:t>867 hrs SAVED </a:t>
+            </a:r>
+          </a:p>
+        </p:txBody>
+      </p:sp>
+      <p:sp>
+        <p:nvSpPr>
+          <p:cNvPr id="34" name="TextBox 33"/>
+          <p:cNvSpPr txBox="1"/>
+          <p:nvPr/>
+        </p:nvSpPr>
+        <p:spPr>
+          <a:xfrm>
+            <a:off x="5120640" y="4956048"/>
+            <a:ext cx="1371600" cy="228600"/>
+          </a:xfrm>
+          <a:prstGeom prst="rect">
+            <a:avLst/>
+          </a:prstGeom>
+          <a:noFill/>
+        </p:spPr>
+        <p:txBody>
+          <a:bodyPr wrap="square" anchor="t">
+            <a:spAutoFit/>
+          </a:bodyPr>
+          <a:lstStyle/>
+          <a:p>
+            <a:pPr algn="l">
+              <a:defRPr sz="1100" b="1">
+                <a:solidFill>
+                  <a:srgbClr val="FFCC00"/>
+                </a:solidFill>
+                <a:latin typeface="Calibri"/>
+              </a:defRPr>
+            </a:pPr>
+            <a:r>
+              <a:t>*($30k)*</a:t>
+            </a:r>
+          </a:p>
+        </p:txBody>
+      </p:sp>
+      <p:sp>
+        <p:nvSpPr>
+          <p:cNvPr id="35" name="TextBox 34"/>
+          <p:cNvSpPr txBox="1"/>
+          <p:nvPr/>
+        </p:nvSpPr>
+        <p:spPr>
+          <a:xfrm>
+            <a:off x="457200" y="5230368"/>
+            <a:ext cx="5943600" cy="228600"/>
+          </a:xfrm>
+          <a:prstGeom prst="rect">
+            <a:avLst/>
+          </a:prstGeom>
+          <a:noFill/>
+        </p:spPr>
+        <p:txBody>
+          <a:bodyPr wrap="square" anchor="t">
+            <a:spAutoFit/>
+          </a:bodyPr>
+          <a:lstStyle/>
+          <a:p>
+            <a:pPr algn="l">
               <a:defRPr sz="1200" b="1">
                 <a:solidFill>
-                  <a:srgbClr val="FFCC00"/>
+                  <a:srgbClr val="00CCFF"/>
                 </a:solidFill>
                 <a:latin typeface="Calibri"/>
               </a:defRPr>
             </a:pPr>
             <a:r>
-              <a:t>RL1: $7,595  |  Program: $30,345  per release (at $35/hr)</a:t>
-            </a:r>
-          </a:p>
-        </p:txBody>
-      </p:sp>
-      <p:sp>
-        <p:nvSpPr>
-          <p:cNvPr id="34" name="Rounded Rectangle 33"/>
+              <a:t>Real Saving — NG-FMS ATS Core EPP</a:t>
+            </a:r>
+          </a:p>
+        </p:txBody>
+      </p:sp>
+      <p:sp>
+        <p:nvSpPr>
+          <p:cNvPr id="36" name="TextBox 35"/>
+          <p:cNvSpPr txBox="1"/>
+          <p:nvPr/>
+        </p:nvSpPr>
+        <p:spPr>
+          <a:xfrm>
+            <a:off x="457200" y="5458968"/>
+            <a:ext cx="5943600" cy="201168"/>
+          </a:xfrm>
+          <a:prstGeom prst="rect">
+            <a:avLst/>
+          </a:prstGeom>
+          <a:noFill/>
+        </p:spPr>
+        <p:txBody>
+          <a:bodyPr wrap="square" anchor="t">
+            <a:spAutoFit/>
+          </a:bodyPr>
+          <a:lstStyle/>
+          <a:p>
+            <a:pPr algn="l">
+              <a:defRPr sz="1000" b="0">
+                <a:solidFill>
+                  <a:srgbClr val="FFFFFF"/>
+                </a:solidFill>
+                <a:latin typeface="Calibri"/>
+              </a:defRPr>
+            </a:pPr>
+            <a:r>
+              <a:t>• 143 defects analysed + pushed in the EPP</a:t>
+            </a:r>
+          </a:p>
+        </p:txBody>
+      </p:sp>
+      <p:sp>
+        <p:nvSpPr>
+          <p:cNvPr id="37" name="TextBox 36"/>
+          <p:cNvSpPr txBox="1"/>
+          <p:nvPr/>
+        </p:nvSpPr>
+        <p:spPr>
+          <a:xfrm>
+            <a:off x="457200" y="5660136"/>
+            <a:ext cx="5943600" cy="201168"/>
+          </a:xfrm>
+          <a:prstGeom prst="rect">
+            <a:avLst/>
+          </a:prstGeom>
+          <a:noFill/>
+        </p:spPr>
+        <p:txBody>
+          <a:bodyPr wrap="square" anchor="t">
+            <a:spAutoFit/>
+          </a:bodyPr>
+          <a:lstStyle/>
+          <a:p>
+            <a:pPr algn="l">
+              <a:defRPr sz="1000" b="0">
+                <a:solidFill>
+                  <a:srgbClr val="CCCCDD"/>
+                </a:solidFill>
+                <a:latin typeface="Calibri"/>
+              </a:defRPr>
+            </a:pPr>
+            <a:r>
+              <a:t>• Manual push: 143 min (≈1 min per defect)   →   Tool push: ~3 min (one batch)</a:t>
+            </a:r>
+          </a:p>
+        </p:txBody>
+      </p:sp>
+      <p:sp>
+        <p:nvSpPr>
+          <p:cNvPr id="38" name="TextBox 37"/>
+          <p:cNvSpPr txBox="1"/>
+          <p:nvPr/>
+        </p:nvSpPr>
+        <p:spPr>
+          <a:xfrm>
+            <a:off x="457200" y="5861303"/>
+            <a:ext cx="5943600" cy="201168"/>
+          </a:xfrm>
+          <a:prstGeom prst="rect">
+            <a:avLst/>
+          </a:prstGeom>
+          <a:noFill/>
+        </p:spPr>
+        <p:txBody>
+          <a:bodyPr wrap="square" anchor="t">
+            <a:spAutoFit/>
+          </a:bodyPr>
+          <a:lstStyle/>
+          <a:p>
+            <a:pPr algn="l">
+              <a:defRPr sz="1000" b="1">
+                <a:solidFill>
+                  <a:srgbClr val="33FF88"/>
+                </a:solidFill>
+                <a:latin typeface="Calibri"/>
+              </a:defRPr>
+            </a:pPr>
+            <a:r>
+              <a:t>• Saved on push: ~140 min ($84) (≈99% faster, 2.4 hrs)</a:t>
+            </a:r>
+          </a:p>
+        </p:txBody>
+      </p:sp>
+      <p:sp>
+        <p:nvSpPr>
+          <p:cNvPr id="39" name="TextBox 38"/>
+          <p:cNvSpPr txBox="1"/>
+          <p:nvPr/>
+        </p:nvSpPr>
+        <p:spPr>
+          <a:xfrm>
+            <a:off x="457200" y="6117336"/>
+            <a:ext cx="10972800" cy="228600"/>
+          </a:xfrm>
+          <a:prstGeom prst="rect">
+            <a:avLst/>
+          </a:prstGeom>
+          <a:noFill/>
+        </p:spPr>
+        <p:txBody>
+          <a:bodyPr wrap="square" anchor="t">
+            <a:spAutoFit/>
+          </a:bodyPr>
+          <a:lstStyle/>
+          <a:p>
+            <a:pPr algn="l">
+              <a:defRPr sz="1000" b="1">
+                <a:solidFill>
+                  <a:srgbClr val="FF9933"/>
+                </a:solidFill>
+                <a:latin typeface="Calibri"/>
+              </a:defRPr>
+            </a:pPr>
+            <a:r>
+              <a:t>Future Targeted programs are  Datalink(787,AIMS,EPIC), TXD along all CNS products and all other HonAero Departments....</a:t>
+            </a:r>
+          </a:p>
+        </p:txBody>
+      </p:sp>
+      <p:sp>
+        <p:nvSpPr>
+          <p:cNvPr id="40" name="Rounded Rectangle 39"/>
           <p:cNvSpPr/>
           <p:nvPr/>
         </p:nvSpPr>
@@ -4502,7 +4718,7 @@
       </p:sp>
       <p:sp>
         <p:nvSpPr>
-          <p:cNvPr id="35" name="TextBox 34"/>
+          <p:cNvPr id="41" name="TextBox 40"/>
           <p:cNvSpPr txBox="1"/>
           <p:nvPr/>
         </p:nvSpPr>
@@ -4538,7 +4754,7 @@
       </p:sp>
       <p:sp>
         <p:nvSpPr>
-          <p:cNvPr id="36" name="Right Arrow 35"/>
+          <p:cNvPr id="42" name="Right Arrow 41"/>
           <p:cNvSpPr/>
           <p:nvPr/>
         </p:nvSpPr>
@@ -4581,7 +4797,7 @@
       </p:sp>
       <p:sp>
         <p:nvSpPr>
-          <p:cNvPr id="37" name="Rounded Rectangle 36"/>
+          <p:cNvPr id="43" name="Rounded Rectangle 42"/>
           <p:cNvSpPr/>
           <p:nvPr/>
         </p:nvSpPr>
@@ -4643,7 +4859,7 @@
       </p:sp>
       <p:sp>
         <p:nvSpPr>
-          <p:cNvPr id="38" name="TextBox 37"/>
+          <p:cNvPr id="44" name="TextBox 43"/>
           <p:cNvSpPr txBox="1"/>
           <p:nvPr/>
         </p:nvSpPr>
@@ -4679,7 +4895,7 @@
       </p:sp>
       <p:sp>
         <p:nvSpPr>
-          <p:cNvPr id="39" name="TextBox 38"/>
+          <p:cNvPr id="45" name="TextBox 44"/>
           <p:cNvSpPr txBox="1"/>
           <p:nvPr/>
         </p:nvSpPr>
@@ -4715,7 +4931,7 @@
       </p:sp>
       <p:sp>
         <p:nvSpPr>
-          <p:cNvPr id="40" name="Down Arrow 39"/>
+          <p:cNvPr id="46" name="Down Arrow 45"/>
           <p:cNvSpPr/>
           <p:nvPr/>
         </p:nvSpPr>
@@ -4758,7 +4974,7 @@
       </p:sp>
       <p:sp>
         <p:nvSpPr>
-          <p:cNvPr id="41" name="Rounded Rectangle 40"/>
+          <p:cNvPr id="47" name="Rounded Rectangle 46"/>
           <p:cNvSpPr/>
           <p:nvPr/>
         </p:nvSpPr>
@@ -4832,7 +5048,7 @@
       </p:sp>
       <p:sp>
         <p:nvSpPr>
-          <p:cNvPr id="42" name="TextBox 41"/>
+          <p:cNvPr id="48" name="TextBox 47"/>
           <p:cNvSpPr txBox="1"/>
           <p:nvPr/>
         </p:nvSpPr>
@@ -4868,7 +5084,7 @@
       </p:sp>
       <p:sp>
         <p:nvSpPr>
-          <p:cNvPr id="43" name="Down Arrow 42"/>
+          <p:cNvPr id="49" name="Down Arrow 48"/>
           <p:cNvSpPr/>
           <p:nvPr/>
         </p:nvSpPr>
@@ -4911,7 +5127,7 @@
       </p:sp>
       <p:sp>
         <p:nvSpPr>
-          <p:cNvPr id="44" name="Rounded Rectangle 43"/>
+          <p:cNvPr id="50" name="Rounded Rectangle 49"/>
           <p:cNvSpPr/>
           <p:nvPr/>
         </p:nvSpPr>
@@ -4985,7 +5201,7 @@
       </p:sp>
       <p:sp>
         <p:nvSpPr>
-          <p:cNvPr id="45" name="TextBox 44"/>
+          <p:cNvPr id="51" name="TextBox 50"/>
           <p:cNvSpPr txBox="1"/>
           <p:nvPr/>
         </p:nvSpPr>

</xml_diff>

<commit_message>
Update slide formatting: increase font size to match deck, balance layout and contrast
Co-authored-by: arena-agent <297053741+arena-agent@users.noreply.github.com>
</commit_message>
<xml_diff>
--- a/Coverity_Findings_Analyzer.pptx
+++ b/Coverity_Findings_Analyzer.pptx
@@ -4254,8 +4254,8 @@
         </p:nvSpPr>
         <p:spPr>
           <a:xfrm>
-            <a:off x="457200" y="4727448"/>
-            <a:ext cx="4389120" cy="228600"/>
+            <a:off x="457200" y="4709159"/>
+            <a:ext cx="4572000" cy="228600"/>
           </a:xfrm>
           <a:prstGeom prst="rect">
             <a:avLst/>
@@ -4269,7 +4269,7 @@
           <a:lstStyle/>
           <a:p>
             <a:pPr algn="l">
-              <a:defRPr sz="1100" b="0">
+              <a:defRPr sz="1200" b="0">
                 <a:solidFill>
                   <a:srgbClr val="FFFFFF"/>
                 </a:solidFill>
@@ -4290,7 +4290,7 @@
         </p:nvSpPr>
         <p:spPr>
           <a:xfrm>
-            <a:off x="4023360" y="4727448"/>
+            <a:off x="4389120" y="4709159"/>
             <a:ext cx="1645920" cy="228600"/>
           </a:xfrm>
           <a:prstGeom prst="rect">
@@ -4305,7 +4305,7 @@
           <a:lstStyle/>
           <a:p>
             <a:pPr algn="l">
-              <a:defRPr sz="1100" b="1">
+              <a:defRPr sz="1200" b="1">
                 <a:solidFill>
                   <a:srgbClr val="FF6B00"/>
                 </a:solidFill>
@@ -4326,7 +4326,7 @@
         </p:nvSpPr>
         <p:spPr>
           <a:xfrm>
-            <a:off x="5120640" y="4727448"/>
+            <a:off x="5577840" y="4709159"/>
             <a:ext cx="1371600" cy="228600"/>
           </a:xfrm>
           <a:prstGeom prst="rect">
@@ -4341,7 +4341,7 @@
           <a:lstStyle/>
           <a:p>
             <a:pPr algn="l">
-              <a:defRPr sz="1100" b="1">
+              <a:defRPr sz="1200" b="1">
                 <a:solidFill>
                   <a:srgbClr val="FFCC00"/>
                 </a:solidFill>
@@ -4362,8 +4362,8 @@
         </p:nvSpPr>
         <p:spPr>
           <a:xfrm>
-            <a:off x="457200" y="4956048"/>
-            <a:ext cx="4389120" cy="228600"/>
+            <a:off x="457200" y="4946903"/>
+            <a:ext cx="4572000" cy="228600"/>
           </a:xfrm>
           <a:prstGeom prst="rect">
             <a:avLst/>
@@ -4377,7 +4377,7 @@
           <a:lstStyle/>
           <a:p>
             <a:pPr algn="l">
-              <a:defRPr sz="1100" b="0">
+              <a:defRPr sz="1200" b="0">
                 <a:solidFill>
                   <a:srgbClr val="FFFFFF"/>
                 </a:solidFill>
@@ -4398,7 +4398,7 @@
         </p:nvSpPr>
         <p:spPr>
           <a:xfrm>
-            <a:off x="4023360" y="4956048"/>
+            <a:off x="4389120" y="4946903"/>
             <a:ext cx="1645920" cy="228600"/>
           </a:xfrm>
           <a:prstGeom prst="rect">
@@ -4413,7 +4413,7 @@
           <a:lstStyle/>
           <a:p>
             <a:pPr algn="l">
-              <a:defRPr sz="1100" b="1">
+              <a:defRPr sz="1200" b="1">
                 <a:solidFill>
                   <a:srgbClr val="FF6B00"/>
                 </a:solidFill>
@@ -4434,7 +4434,7 @@
         </p:nvSpPr>
         <p:spPr>
           <a:xfrm>
-            <a:off x="5120640" y="4956048"/>
+            <a:off x="5577840" y="4946903"/>
             <a:ext cx="1371600" cy="228600"/>
           </a:xfrm>
           <a:prstGeom prst="rect">
@@ -4449,7 +4449,7 @@
           <a:lstStyle/>
           <a:p>
             <a:pPr algn="l">
-              <a:defRPr sz="1100" b="1">
+              <a:defRPr sz="1200" b="1">
                 <a:solidFill>
                   <a:srgbClr val="FFCC00"/>
                 </a:solidFill>
@@ -4470,7 +4470,7 @@
         </p:nvSpPr>
         <p:spPr>
           <a:xfrm>
-            <a:off x="457200" y="5230368"/>
+            <a:off x="457200" y="5202935"/>
             <a:ext cx="5943600" cy="228600"/>
           </a:xfrm>
           <a:prstGeom prst="rect">
@@ -4506,7 +4506,7 @@
         </p:nvSpPr>
         <p:spPr>
           <a:xfrm>
-            <a:off x="457200" y="5458968"/>
+            <a:off x="457200" y="5440679"/>
             <a:ext cx="5943600" cy="201168"/>
           </a:xfrm>
           <a:prstGeom prst="rect">
@@ -4521,7 +4521,7 @@
           <a:lstStyle/>
           <a:p>
             <a:pPr algn="l">
-              <a:defRPr sz="1000" b="0">
+              <a:defRPr sz="1100" b="0">
                 <a:solidFill>
                   <a:srgbClr val="FFFFFF"/>
                 </a:solidFill>
@@ -4543,7 +4543,7 @@
         <p:spPr>
           <a:xfrm>
             <a:off x="457200" y="5660136"/>
-            <a:ext cx="5943600" cy="201168"/>
+            <a:ext cx="6858000" cy="201168"/>
           </a:xfrm>
           <a:prstGeom prst="rect">
             <a:avLst/>
@@ -4557,7 +4557,7 @@
           <a:lstStyle/>
           <a:p>
             <a:pPr algn="l">
-              <a:defRPr sz="1000" b="0">
+              <a:defRPr sz="1100" b="0">
                 <a:solidFill>
                   <a:srgbClr val="CCCCDD"/>
                 </a:solidFill>
@@ -4578,7 +4578,7 @@
         </p:nvSpPr>
         <p:spPr>
           <a:xfrm>
-            <a:off x="457200" y="5861303"/>
+            <a:off x="457200" y="5879592"/>
             <a:ext cx="5943600" cy="201168"/>
           </a:xfrm>
           <a:prstGeom prst="rect">
@@ -4593,7 +4593,7 @@
           <a:lstStyle/>
           <a:p>
             <a:pPr algn="l">
-              <a:defRPr sz="1000" b="1">
+              <a:defRPr sz="1100" b="1">
                 <a:solidFill>
                   <a:srgbClr val="33FF88"/>
                 </a:solidFill>
@@ -4614,7 +4614,7 @@
         </p:nvSpPr>
         <p:spPr>
           <a:xfrm>
-            <a:off x="457200" y="6117336"/>
+            <a:off x="457200" y="6135624"/>
             <a:ext cx="10972800" cy="228600"/>
           </a:xfrm>
           <a:prstGeom prst="rect">
@@ -4629,7 +4629,7 @@
           <a:lstStyle/>
           <a:p>
             <a:pPr algn="l">
-              <a:defRPr sz="1000" b="1">
+              <a:defRPr sz="1100" b="1">
                 <a:solidFill>
                   <a:srgbClr val="FF9933"/>
                 </a:solidFill>

</xml_diff>

<commit_message>
Harmonize section headers, scale sections proportionally, and highlight enlarged $7k and $30k figures
Co-authored-by: arena-agent <297053741+arena-agent@users.noreply.github.com>
</commit_message>
<xml_diff>
--- a/Coverity_Findings_Analyzer.pptx
+++ b/Coverity_Findings_Analyzer.pptx
@@ -3111,7 +3111,7 @@
             <a:avLst/>
           </a:prstGeom>
           <a:solidFill>
-            <a:srgbClr val="FF6B00"/>
+            <a:srgbClr val="FA7024"/>
           </a:solidFill>
           <a:ln>
             <a:noFill/>
@@ -3164,7 +3164,7 @@
             <a:pPr algn="l">
               <a:defRPr sz="2600" b="1">
                 <a:solidFill>
-                  <a:srgbClr val="FF6B00"/>
+                  <a:srgbClr val="FA7024"/>
                 </a:solidFill>
                 <a:latin typeface="Calibri"/>
               </a:defRPr>
@@ -3200,7 +3200,7 @@
             <a:pPr algn="ctr">
               <a:defRPr sz="1400" b="0">
                 <a:solidFill>
-                  <a:srgbClr val="CCCCDD"/>
+                  <a:srgbClr val="D7DEEB"/>
                 </a:solidFill>
                 <a:latin typeface="Calibri"/>
               </a:defRPr>
@@ -3226,7 +3226,7 @@
             <a:avLst/>
           </a:prstGeom>
           <a:solidFill>
-            <a:srgbClr val="FF6B00"/>
+            <a:srgbClr val="FA7024"/>
           </a:solidFill>
           <a:ln>
             <a:noFill/>
@@ -3263,7 +3263,7 @@
         <p:spPr>
           <a:xfrm>
             <a:off x="365760" y="1051560"/>
-            <a:ext cx="3657600" cy="320040"/>
+            <a:ext cx="3291840" cy="320040"/>
           </a:xfrm>
           <a:prstGeom prst="rect">
             <a:avLst/>
@@ -3277,15 +3277,15 @@
           <a:lstStyle/>
           <a:p>
             <a:pPr algn="l">
-              <a:defRPr sz="1600" b="1">
-                <a:solidFill>
-                  <a:srgbClr val="FF6B00"/>
+              <a:defRPr sz="1500" b="1">
+                <a:solidFill>
+                  <a:srgbClr val="FA7024"/>
                 </a:solidFill>
                 <a:latin typeface="Calibri"/>
               </a:defRPr>
             </a:pPr>
             <a:r>
-              <a:t>  CORE FEATURES</a:t>
+              <a:t>🎯  CORE FEATURES</a:t>
             </a:r>
           </a:p>
         </p:txBody>
@@ -3299,7 +3299,7 @@
         <p:spPr>
           <a:xfrm>
             <a:off x="457200" y="1417320"/>
-            <a:ext cx="3474720" cy="201168"/>
+            <a:ext cx="3200400" cy="201168"/>
           </a:xfrm>
           <a:prstGeom prst="rect">
             <a:avLst/>
@@ -3313,7 +3313,7 @@
           <a:lstStyle/>
           <a:p>
             <a:pPr algn="l">
-              <a:defRPr sz="1100" b="1">
+              <a:defRPr sz="1050" b="1">
                 <a:solidFill>
                   <a:srgbClr val="FFFFFF"/>
                 </a:solidFill>
@@ -3334,8 +3334,8 @@
         </p:nvSpPr>
         <p:spPr>
           <a:xfrm>
-            <a:off x="457200" y="1600200"/>
-            <a:ext cx="3474720" cy="201168"/>
+            <a:off x="457200" y="1581912"/>
+            <a:ext cx="3200400" cy="182880"/>
           </a:xfrm>
           <a:prstGeom prst="rect">
             <a:avLst/>
@@ -3349,15 +3349,15 @@
           <a:lstStyle/>
           <a:p>
             <a:pPr algn="l">
-              <a:defRPr sz="1000" b="0">
-                <a:solidFill>
-                  <a:srgbClr val="CCCCDD"/>
+              <a:defRPr sz="950" b="0">
+                <a:solidFill>
+                  <a:srgbClr val="D7DEEB"/>
                 </a:solidFill>
                 <a:latin typeface="Calibri"/>
               </a:defRPr>
             </a:pPr>
             <a:r>
-              <a:t>  DO-178C, MISRA, CERT</a:t>
+              <a:t>- DO-178C, MISRA, CERT</a:t>
             </a:r>
           </a:p>
         </p:txBody>
@@ -3370,8 +3370,8 @@
         </p:nvSpPr>
         <p:spPr>
           <a:xfrm>
-            <a:off x="457200" y="1965960"/>
-            <a:ext cx="3474720" cy="201168"/>
+            <a:off x="457200" y="1874519"/>
+            <a:ext cx="3200400" cy="201168"/>
           </a:xfrm>
           <a:prstGeom prst="rect">
             <a:avLst/>
@@ -3385,7 +3385,7 @@
           <a:lstStyle/>
           <a:p>
             <a:pPr algn="l">
-              <a:defRPr sz="1100" b="1">
+              <a:defRPr sz="1050" b="1">
                 <a:solidFill>
                   <a:srgbClr val="FFFFFF"/>
                 </a:solidFill>
@@ -3406,8 +3406,8 @@
         </p:nvSpPr>
         <p:spPr>
           <a:xfrm>
-            <a:off x="457200" y="2148840"/>
-            <a:ext cx="3474720" cy="201168"/>
+            <a:off x="457200" y="2039112"/>
+            <a:ext cx="3200400" cy="182880"/>
           </a:xfrm>
           <a:prstGeom prst="rect">
             <a:avLst/>
@@ -3421,15 +3421,15 @@
           <a:lstStyle/>
           <a:p>
             <a:pPr algn="l">
-              <a:defRPr sz="1000" b="0">
-                <a:solidFill>
-                  <a:srgbClr val="CCCCDD"/>
+              <a:defRPr sz="950" b="0">
+                <a:solidFill>
+                  <a:srgbClr val="D7DEEB"/>
                 </a:solidFill>
                 <a:latin typeface="Calibri"/>
               </a:defRPr>
             </a:pPr>
             <a:r>
-              <a:t>  Source never leaves machine</a:t>
+              <a:t>- Source never leaves machine</a:t>
             </a:r>
           </a:p>
         </p:txBody>
@@ -3442,8 +3442,8 @@
         </p:nvSpPr>
         <p:spPr>
           <a:xfrm>
-            <a:off x="457200" y="2514600"/>
-            <a:ext cx="3474720" cy="201168"/>
+            <a:off x="457200" y="2331720"/>
+            <a:ext cx="3200400" cy="201168"/>
           </a:xfrm>
           <a:prstGeom prst="rect">
             <a:avLst/>
@@ -3457,7 +3457,7 @@
           <a:lstStyle/>
           <a:p>
             <a:pPr algn="l">
-              <a:defRPr sz="1100" b="1">
+              <a:defRPr sz="1050" b="1">
                 <a:solidFill>
                   <a:srgbClr val="FFFFFF"/>
                 </a:solidFill>
@@ -3478,8 +3478,8 @@
         </p:nvSpPr>
         <p:spPr>
           <a:xfrm>
-            <a:off x="457200" y="2697480"/>
-            <a:ext cx="3474720" cy="201168"/>
+            <a:off x="457200" y="2496312"/>
+            <a:ext cx="3200400" cy="182880"/>
           </a:xfrm>
           <a:prstGeom prst="rect">
             <a:avLst/>
@@ -3493,15 +3493,15 @@
           <a:lstStyle/>
           <a:p>
             <a:pPr algn="l">
-              <a:defRPr sz="1000" b="0">
-                <a:solidFill>
-                  <a:srgbClr val="CCCCDD"/>
+              <a:defRPr sz="950" b="0">
+                <a:solidFill>
+                  <a:srgbClr val="D7DEEB"/>
                 </a:solidFill>
                 <a:latin typeface="Calibri"/>
               </a:defRPr>
             </a:pPr>
             <a:r>
-              <a:t>  Runs 100% offline</a:t>
+              <a:t>- Runs 100% offline</a:t>
             </a:r>
           </a:p>
         </p:txBody>
@@ -3514,8 +3514,8 @@
         </p:nvSpPr>
         <p:spPr>
           <a:xfrm>
-            <a:off x="457200" y="3063240"/>
-            <a:ext cx="3474720" cy="201168"/>
+            <a:off x="457200" y="2788920"/>
+            <a:ext cx="3200400" cy="201168"/>
           </a:xfrm>
           <a:prstGeom prst="rect">
             <a:avLst/>
@@ -3529,7 +3529,7 @@
           <a:lstStyle/>
           <a:p>
             <a:pPr algn="l">
-              <a:defRPr sz="1100" b="1">
+              <a:defRPr sz="1050" b="1">
                 <a:solidFill>
                   <a:srgbClr val="FFFFFF"/>
                 </a:solidFill>
@@ -3550,8 +3550,8 @@
         </p:nvSpPr>
         <p:spPr>
           <a:xfrm>
-            <a:off x="457200" y="3246120"/>
-            <a:ext cx="3474720" cy="201168"/>
+            <a:off x="457200" y="2953512"/>
+            <a:ext cx="3200400" cy="182880"/>
           </a:xfrm>
           <a:prstGeom prst="rect">
             <a:avLst/>
@@ -3565,15 +3565,15 @@
           <a:lstStyle/>
           <a:p>
             <a:pPr algn="l">
-              <a:defRPr sz="1000" b="0">
-                <a:solidFill>
-                  <a:srgbClr val="CCCCDD"/>
+              <a:defRPr sz="950" b="0">
+                <a:solidFill>
+                  <a:srgbClr val="D7DEEB"/>
                 </a:solidFill>
                 <a:latin typeface="Calibri"/>
               </a:defRPr>
             </a:pPr>
             <a:r>
-              <a:t>  80% reduction</a:t>
+              <a:t>- 80% reduction</a:t>
             </a:r>
           </a:p>
         </p:txBody>
@@ -3586,7 +3586,7 @@
         </p:nvSpPr>
         <p:spPr>
           <a:xfrm>
-            <a:off x="4206240" y="1051560"/>
+            <a:off x="3840480" y="1051560"/>
             <a:ext cx="3200400" cy="320040"/>
           </a:xfrm>
           <a:prstGeom prst="rect">
@@ -3601,9 +3601,9 @@
           <a:lstStyle/>
           <a:p>
             <a:pPr algn="l">
-              <a:defRPr sz="1600" b="1">
-                <a:solidFill>
-                  <a:srgbClr val="FF6B00"/>
+              <a:defRPr sz="1500" b="1">
+                <a:solidFill>
+                  <a:srgbClr val="FA7024"/>
                 </a:solidFill>
                 <a:latin typeface="Calibri"/>
               </a:defRPr>
@@ -3622,8 +3622,8 @@
         </p:nvSpPr>
         <p:spPr>
           <a:xfrm>
-            <a:off x="4206240" y="1417320"/>
-            <a:ext cx="2103120" cy="384048"/>
+            <a:off x="3840480" y="1417320"/>
+            <a:ext cx="1691640" cy="329184"/>
           </a:xfrm>
           <a:prstGeom prst="roundRect">
             <a:avLst/>
@@ -3633,7 +3633,7 @@
           </a:solidFill>
           <a:ln w="12700">
             <a:solidFill>
-              <a:srgbClr val="FF6B00"/>
+              <a:srgbClr val="FA7024"/>
             </a:solidFill>
           </a:ln>
         </p:spPr>
@@ -3656,9 +3656,9 @@
           <a:lstStyle/>
           <a:p>
             <a:pPr algn="ctr">
-              <a:defRPr sz="1100" b="1">
-                <a:solidFill>
-                  <a:srgbClr val="FF4444"/>
+              <a:defRPr sz="1000" b="1">
+                <a:solidFill>
+                  <a:srgbClr val="FF5555"/>
                 </a:solidFill>
               </a:defRPr>
             </a:pPr>
@@ -3676,8 +3676,8 @@
         </p:nvSpPr>
         <p:spPr>
           <a:xfrm>
-            <a:off x="6355079" y="1417320"/>
-            <a:ext cx="2103120" cy="384048"/>
+            <a:off x="5577840" y="1417320"/>
+            <a:ext cx="1691640" cy="329184"/>
           </a:xfrm>
           <a:prstGeom prst="roundRect">
             <a:avLst/>
@@ -3687,7 +3687,7 @@
           </a:solidFill>
           <a:ln w="12700">
             <a:solidFill>
-              <a:srgbClr val="FF6B00"/>
+              <a:srgbClr val="FA7024"/>
             </a:solidFill>
           </a:ln>
         </p:spPr>
@@ -3710,7 +3710,7 @@
           <a:lstStyle/>
           <a:p>
             <a:pPr algn="ctr">
-              <a:defRPr sz="1100" b="1">
+              <a:defRPr sz="1000" b="1">
                 <a:solidFill>
                   <a:srgbClr val="00CC66"/>
                 </a:solidFill>
@@ -3730,8 +3730,8 @@
         </p:nvSpPr>
         <p:spPr>
           <a:xfrm>
-            <a:off x="4206240" y="1837943"/>
-            <a:ext cx="2103120" cy="384048"/>
+            <a:off x="3840480" y="1783080"/>
+            <a:ext cx="1691640" cy="329184"/>
           </a:xfrm>
           <a:prstGeom prst="roundRect">
             <a:avLst/>
@@ -3762,14 +3762,19 @@
           <a:lstStyle/>
           <a:p>
             <a:pPr>
-              <a:defRPr sz="900">
-                <a:solidFill>
-                  <a:srgbClr val="CCCCDD"/>
+              <a:defRPr sz="850">
+                <a:solidFill>
+                  <a:srgbClr val="D7DEEB"/>
                 </a:solidFill>
               </a:defRPr>
             </a:pPr>
             <a:r>
-              <a:t>⏱ 10-15 min / defect</a:t>
+              <a:t>10-15 minutes</a:t>
+            </a:r>
+          </a:p>
+          <a:p>
+            <a:r>
+              <a:t>per defect</a:t>
             </a:r>
           </a:p>
         </p:txBody>
@@ -3782,8 +3787,8 @@
         </p:nvSpPr>
         <p:spPr>
           <a:xfrm>
-            <a:off x="6355079" y="1837943"/>
-            <a:ext cx="2103120" cy="384048"/>
+            <a:off x="5577840" y="1783080"/>
+            <a:ext cx="1691640" cy="329184"/>
           </a:xfrm>
           <a:prstGeom prst="roundRect">
             <a:avLst/>
@@ -3814,14 +3819,19 @@
           <a:lstStyle/>
           <a:p>
             <a:pPr>
-              <a:defRPr sz="900">
+              <a:defRPr sz="850">
                 <a:solidFill>
                   <a:srgbClr val="FFFFFF"/>
                 </a:solidFill>
               </a:defRPr>
             </a:pPr>
             <a:r>
-              <a:t>⚡ 1-2 min / defect</a:t>
+              <a:t>1-2 minutes</a:t>
+            </a:r>
+          </a:p>
+          <a:p>
+            <a:r>
+              <a:t>per defect</a:t>
             </a:r>
           </a:p>
         </p:txBody>
@@ -3834,8 +3844,8 @@
         </p:nvSpPr>
         <p:spPr>
           <a:xfrm>
-            <a:off x="4206240" y="2258568"/>
-            <a:ext cx="2103120" cy="384048"/>
+            <a:off x="3840480" y="2148840"/>
+            <a:ext cx="1691640" cy="329184"/>
           </a:xfrm>
           <a:prstGeom prst="roundRect">
             <a:avLst/>
@@ -3866,14 +3876,19 @@
           <a:lstStyle/>
           <a:p>
             <a:pPr>
-              <a:defRPr sz="900">
-                <a:solidFill>
-                  <a:srgbClr val="CCCCDD"/>
+              <a:defRPr sz="850">
+                <a:solidFill>
+                  <a:srgbClr val="D7DEEB"/>
                 </a:solidFill>
               </a:defRPr>
             </a:pPr>
             <a:r>
-              <a:t>🔍 Source Code Investigation Required</a:t>
+              <a:t>Source Code Investigation</a:t>
+            </a:r>
+          </a:p>
+          <a:p>
+            <a:r>
+              <a:t>Required</a:t>
             </a:r>
           </a:p>
         </p:txBody>
@@ -3886,8 +3901,8 @@
         </p:nvSpPr>
         <p:spPr>
           <a:xfrm>
-            <a:off x="6355079" y="2258568"/>
-            <a:ext cx="2103120" cy="384048"/>
+            <a:off x="5577840" y="2148840"/>
+            <a:ext cx="1691640" cy="329184"/>
           </a:xfrm>
           <a:prstGeom prst="roundRect">
             <a:avLst/>
@@ -3918,14 +3933,19 @@
           <a:lstStyle/>
           <a:p>
             <a:pPr>
-              <a:defRPr sz="900">
+              <a:defRPr sz="850">
                 <a:solidFill>
                   <a:srgbClr val="FFFFFF"/>
                 </a:solidFill>
               </a:defRPr>
             </a:pPr>
             <a:r>
-              <a:t>🤖 Automated Analysis</a:t>
+              <a:t>Automated</a:t>
+            </a:r>
+          </a:p>
+          <a:p>
+            <a:r>
+              <a:t>Analysis</a:t>
             </a:r>
           </a:p>
         </p:txBody>
@@ -3938,8 +3958,8 @@
         </p:nvSpPr>
         <p:spPr>
           <a:xfrm>
-            <a:off x="4206240" y="2679191"/>
-            <a:ext cx="2103120" cy="384048"/>
+            <a:off x="3840480" y="2514600"/>
+            <a:ext cx="1691640" cy="329184"/>
           </a:xfrm>
           <a:prstGeom prst="roundRect">
             <a:avLst/>
@@ -3970,14 +3990,19 @@
           <a:lstStyle/>
           <a:p>
             <a:pPr>
-              <a:defRPr sz="900">
-                <a:solidFill>
-                  <a:srgbClr val="CCCCDD"/>
+              <a:defRPr sz="850">
+                <a:solidFill>
+                  <a:srgbClr val="D7DEEB"/>
                 </a:solidFill>
               </a:defRPr>
             </a:pPr>
             <a:r>
-              <a:t>🧠 Context Analysis Required</a:t>
+              <a:t>Context Analysis</a:t>
+            </a:r>
+          </a:p>
+          <a:p>
+            <a:r>
+              <a:t>Required</a:t>
             </a:r>
           </a:p>
         </p:txBody>
@@ -3990,8 +4015,8 @@
         </p:nvSpPr>
         <p:spPr>
           <a:xfrm>
-            <a:off x="6355079" y="2679191"/>
-            <a:ext cx="2103120" cy="384048"/>
+            <a:off x="5577840" y="2514600"/>
+            <a:ext cx="1691640" cy="329184"/>
           </a:xfrm>
           <a:prstGeom prst="roundRect">
             <a:avLst/>
@@ -4022,14 +4047,19 @@
           <a:lstStyle/>
           <a:p>
             <a:pPr>
-              <a:defRPr sz="900">
+              <a:defRPr sz="850">
                 <a:solidFill>
                   <a:srgbClr val="FFFFFF"/>
                 </a:solidFill>
               </a:defRPr>
             </a:pPr>
             <a:r>
-              <a:t>✅ One Controlled Flow</a:t>
+              <a:t>One Controlled</a:t>
+            </a:r>
+          </a:p>
+          <a:p>
+            <a:r>
+              <a:t>Flow</a:t>
             </a:r>
           </a:p>
         </p:txBody>
@@ -4042,8 +4072,8 @@
         </p:nvSpPr>
         <p:spPr>
           <a:xfrm>
-            <a:off x="4206240" y="3099815"/>
-            <a:ext cx="2103120" cy="384048"/>
+            <a:off x="3840480" y="2880360"/>
+            <a:ext cx="1691640" cy="329184"/>
           </a:xfrm>
           <a:prstGeom prst="roundRect">
             <a:avLst/>
@@ -4074,14 +4104,19 @@
           <a:lstStyle/>
           <a:p>
             <a:pPr>
-              <a:defRPr sz="900">
-                <a:solidFill>
-                  <a:srgbClr val="CCCCDD"/>
+              <a:defRPr sz="850">
+                <a:solidFill>
+                  <a:srgbClr val="D7DEEB"/>
                 </a:solidFill>
               </a:defRPr>
             </a:pPr>
             <a:r>
-              <a:t>📝 Disposition &amp; Documentation Required</a:t>
+              <a:t>Disposition &amp;</a:t>
+            </a:r>
+          </a:p>
+          <a:p>
+            <a:r>
+              <a:t>Documentation Required</a:t>
             </a:r>
           </a:p>
         </p:txBody>
@@ -4094,8 +4129,8 @@
         </p:nvSpPr>
         <p:spPr>
           <a:xfrm>
-            <a:off x="6355079" y="3099815"/>
-            <a:ext cx="2103120" cy="384048"/>
+            <a:off x="5577840" y="2880360"/>
+            <a:ext cx="1691640" cy="329184"/>
           </a:xfrm>
           <a:prstGeom prst="roundRect">
             <a:avLst/>
@@ -4126,14 +4161,19 @@
           <a:lstStyle/>
           <a:p>
             <a:pPr>
-              <a:defRPr sz="900">
+              <a:defRPr sz="850">
                 <a:solidFill>
                   <a:srgbClr val="FFFFFF"/>
                 </a:solidFill>
               </a:defRPr>
             </a:pPr>
             <a:r>
-              <a:t>📊 Higher Quality</a:t>
+              <a:t>Higher</a:t>
+            </a:r>
+          </a:p>
+          <a:p>
+            <a:r>
+              <a:t>Quality</a:t>
             </a:r>
           </a:p>
         </p:txBody>
@@ -4146,8 +4186,8 @@
         </p:nvSpPr>
         <p:spPr>
           <a:xfrm>
-            <a:off x="4480559" y="3593591"/>
-            <a:ext cx="2286000" cy="457200"/>
+            <a:off x="4937760" y="3282696"/>
+            <a:ext cx="2286000" cy="365760"/>
           </a:xfrm>
           <a:prstGeom prst="rect">
             <a:avLst/>
@@ -4161,9 +4201,9 @@
           <a:lstStyle/>
           <a:p>
             <a:pPr algn="l">
-              <a:defRPr sz="2800" b="1">
-                <a:solidFill>
-                  <a:srgbClr val="FF6B00"/>
+              <a:defRPr sz="2400" b="1">
+                <a:solidFill>
+                  <a:srgbClr val="FA7024"/>
                 </a:solidFill>
                 <a:latin typeface="Calibri"/>
               </a:defRPr>
@@ -4182,8 +4222,8 @@
         </p:nvSpPr>
         <p:spPr>
           <a:xfrm>
-            <a:off x="4480559" y="3941063"/>
-            <a:ext cx="2286000" cy="274320"/>
+            <a:off x="4937760" y="3575303"/>
+            <a:ext cx="2286000" cy="228600"/>
           </a:xfrm>
           <a:prstGeom prst="rect">
             <a:avLst/>
@@ -4197,9 +4237,9 @@
           <a:lstStyle/>
           <a:p>
             <a:pPr algn="l">
-              <a:defRPr sz="1100" b="0">
-                <a:solidFill>
-                  <a:srgbClr val="CCCCDD"/>
+              <a:defRPr sz="1000" b="0">
+                <a:solidFill>
+                  <a:srgbClr val="D7DEEB"/>
                 </a:solidFill>
                 <a:latin typeface="Calibri"/>
               </a:defRPr>
@@ -4218,8 +4258,8 @@
         </p:nvSpPr>
         <p:spPr>
           <a:xfrm>
-            <a:off x="365760" y="4434840"/>
-            <a:ext cx="4114800" cy="320040"/>
+            <a:off x="365760" y="4389120"/>
+            <a:ext cx="5029200" cy="320040"/>
           </a:xfrm>
           <a:prstGeom prst="rect">
             <a:avLst/>
@@ -4233,9 +4273,9 @@
           <a:lstStyle/>
           <a:p>
             <a:pPr algn="l">
-              <a:defRPr sz="1400" b="1">
-                <a:solidFill>
-                  <a:srgbClr val="FF6B00"/>
+              <a:defRPr sz="1500" b="1">
+                <a:solidFill>
+                  <a:srgbClr val="FA7024"/>
                 </a:solidFill>
                 <a:latin typeface="Calibri"/>
               </a:defRPr>
@@ -4254,8 +4294,8 @@
         </p:nvSpPr>
         <p:spPr>
           <a:xfrm>
-            <a:off x="457200" y="4709159"/>
-            <a:ext cx="4572000" cy="228600"/>
+            <a:off x="365760" y="4718304"/>
+            <a:ext cx="3108960" cy="228600"/>
           </a:xfrm>
           <a:prstGeom prst="rect">
             <a:avLst/>
@@ -4269,7 +4309,7 @@
           <a:lstStyle/>
           <a:p>
             <a:pPr algn="l">
-              <a:defRPr sz="1200" b="0">
+              <a:defRPr sz="1100" b="0">
                 <a:solidFill>
                   <a:srgbClr val="FFFFFF"/>
                 </a:solidFill>
@@ -4277,7 +4317,7 @@
               </a:defRPr>
             </a:pPr>
             <a:r>
-              <a:t>RL1 (1,000 defects): 250 hrs → 33 hrs = </a:t>
+              <a:t>RL1 (1,000 defects): 250 hrs → 33 hrs =</a:t>
             </a:r>
           </a:p>
         </p:txBody>
@@ -4290,8 +4330,8 @@
         </p:nvSpPr>
         <p:spPr>
           <a:xfrm>
-            <a:off x="4389120" y="4709159"/>
-            <a:ext cx="1645920" cy="228600"/>
+            <a:off x="3383280" y="4718304"/>
+            <a:ext cx="1371600" cy="228600"/>
           </a:xfrm>
           <a:prstGeom prst="rect">
             <a:avLst/>
@@ -4305,29 +4345,83 @@
           <a:lstStyle/>
           <a:p>
             <a:pPr algn="l">
+              <a:defRPr sz="1100" b="1">
+                <a:solidFill>
+                  <a:srgbClr val="FA7024"/>
+                </a:solidFill>
+                <a:latin typeface="Calibri"/>
+              </a:defRPr>
+            </a:pPr>
+            <a:r>
+              <a:t>217 hrs SAVED</a:t>
+            </a:r>
+          </a:p>
+        </p:txBody>
+      </p:sp>
+      <p:sp>
+        <p:nvSpPr>
+          <p:cNvPr id="31" name="Rounded Rectangle 30"/>
+          <p:cNvSpPr/>
+          <p:nvPr/>
+        </p:nvSpPr>
+        <p:spPr>
+          <a:xfrm>
+            <a:off x="4754880" y="4681728"/>
+            <a:ext cx="1097280" cy="256032"/>
+          </a:xfrm>
+          <a:prstGeom prst="roundRect">
+            <a:avLst/>
+          </a:prstGeom>
+          <a:solidFill>
+            <a:srgbClr val="231C05"/>
+          </a:solidFill>
+          <a:ln w="19050">
+            <a:solidFill>
+              <a:srgbClr val="FFE114"/>
+            </a:solidFill>
+          </a:ln>
+        </p:spPr>
+        <p:style>
+          <a:lnRef idx="1">
+            <a:schemeClr val="accent1"/>
+          </a:lnRef>
+          <a:fillRef idx="3">
+            <a:schemeClr val="accent1"/>
+          </a:fillRef>
+          <a:effectRef idx="2">
+            <a:schemeClr val="accent1"/>
+          </a:effectRef>
+          <a:fontRef idx="minor">
+            <a:schemeClr val="lt1"/>
+          </a:fontRef>
+        </p:style>
+        <p:txBody>
+          <a:bodyPr rtlCol="0" anchor="ctr"/>
+          <a:lstStyle/>
+          <a:p>
+            <a:pPr algn="ctr">
               <a:defRPr sz="1200" b="1">
                 <a:solidFill>
-                  <a:srgbClr val="FF6B00"/>
-                </a:solidFill>
-                <a:latin typeface="Calibri"/>
+                  <a:srgbClr val="FFE114"/>
+                </a:solidFill>
               </a:defRPr>
             </a:pPr>
             <a:r>
-              <a:t>217 hrs SAVED </a:t>
-            </a:r>
-          </a:p>
-        </p:txBody>
-      </p:sp>
-      <p:sp>
-        <p:nvSpPr>
-          <p:cNvPr id="31" name="TextBox 30"/>
+              <a:t>★ ($7k) ★</a:t>
+            </a:r>
+          </a:p>
+        </p:txBody>
+      </p:sp>
+      <p:sp>
+        <p:nvSpPr>
+          <p:cNvPr id="32" name="TextBox 31"/>
           <p:cNvSpPr txBox="1"/>
           <p:nvPr/>
         </p:nvSpPr>
         <p:spPr>
           <a:xfrm>
-            <a:off x="5577840" y="4709159"/>
-            <a:ext cx="1371600" cy="228600"/>
+            <a:off x="365760" y="5010912"/>
+            <a:ext cx="3383280" cy="228600"/>
           </a:xfrm>
           <a:prstGeom prst="rect">
             <a:avLst/>
@@ -4341,29 +4435,29 @@
           <a:lstStyle/>
           <a:p>
             <a:pPr algn="l">
-              <a:defRPr sz="1200" b="1">
-                <a:solidFill>
-                  <a:srgbClr val="FFCC00"/>
+              <a:defRPr sz="1100" b="0">
+                <a:solidFill>
+                  <a:srgbClr val="FFFFFF"/>
                 </a:solidFill>
                 <a:latin typeface="Calibri"/>
               </a:defRPr>
             </a:pPr>
             <a:r>
-              <a:t>*($7k)*</a:t>
-            </a:r>
-          </a:p>
-        </p:txBody>
-      </p:sp>
-      <p:sp>
-        <p:nvSpPr>
-          <p:cNvPr id="32" name="TextBox 31"/>
+              <a:t>Program (4,000 defects): 1000 hrs → 133 hrs =</a:t>
+            </a:r>
+          </a:p>
+        </p:txBody>
+      </p:sp>
+      <p:sp>
+        <p:nvSpPr>
+          <p:cNvPr id="33" name="TextBox 32"/>
           <p:cNvSpPr txBox="1"/>
           <p:nvPr/>
         </p:nvSpPr>
         <p:spPr>
           <a:xfrm>
-            <a:off x="457200" y="4946903"/>
-            <a:ext cx="4572000" cy="228600"/>
+            <a:off x="3657600" y="5010912"/>
+            <a:ext cx="1371600" cy="228600"/>
           </a:xfrm>
           <a:prstGeom prst="rect">
             <a:avLst/>
@@ -4377,29 +4471,83 @@
           <a:lstStyle/>
           <a:p>
             <a:pPr algn="l">
-              <a:defRPr sz="1200" b="0">
-                <a:solidFill>
-                  <a:srgbClr val="FFFFFF"/>
+              <a:defRPr sz="1100" b="1">
+                <a:solidFill>
+                  <a:srgbClr val="FA7024"/>
                 </a:solidFill>
                 <a:latin typeface="Calibri"/>
               </a:defRPr>
             </a:pPr>
             <a:r>
-              <a:t>Program (4,000 defects): 1,000 hrs → 133 hrs = </a:t>
-            </a:r>
-          </a:p>
-        </p:txBody>
-      </p:sp>
-      <p:sp>
-        <p:nvSpPr>
-          <p:cNvPr id="33" name="TextBox 32"/>
+              <a:t>867 hrs SAVED</a:t>
+            </a:r>
+          </a:p>
+        </p:txBody>
+      </p:sp>
+      <p:sp>
+        <p:nvSpPr>
+          <p:cNvPr id="34" name="Rounded Rectangle 33"/>
+          <p:cNvSpPr/>
+          <p:nvPr/>
+        </p:nvSpPr>
+        <p:spPr>
+          <a:xfrm>
+            <a:off x="5029200" y="4974336"/>
+            <a:ext cx="1188720" cy="256032"/>
+          </a:xfrm>
+          <a:prstGeom prst="roundRect">
+            <a:avLst/>
+          </a:prstGeom>
+          <a:solidFill>
+            <a:srgbClr val="231C05"/>
+          </a:solidFill>
+          <a:ln w="19050">
+            <a:solidFill>
+              <a:srgbClr val="FFE114"/>
+            </a:solidFill>
+          </a:ln>
+        </p:spPr>
+        <p:style>
+          <a:lnRef idx="1">
+            <a:schemeClr val="accent1"/>
+          </a:lnRef>
+          <a:fillRef idx="3">
+            <a:schemeClr val="accent1"/>
+          </a:fillRef>
+          <a:effectRef idx="2">
+            <a:schemeClr val="accent1"/>
+          </a:effectRef>
+          <a:fontRef idx="minor">
+            <a:schemeClr val="lt1"/>
+          </a:fontRef>
+        </p:style>
+        <p:txBody>
+          <a:bodyPr rtlCol="0" anchor="ctr"/>
+          <a:lstStyle/>
+          <a:p>
+            <a:pPr algn="ctr">
+              <a:defRPr sz="1200" b="1">
+                <a:solidFill>
+                  <a:srgbClr val="FFE114"/>
+                </a:solidFill>
+              </a:defRPr>
+            </a:pPr>
+            <a:r>
+              <a:t>★ ($30k) ★</a:t>
+            </a:r>
+          </a:p>
+        </p:txBody>
+      </p:sp>
+      <p:sp>
+        <p:nvSpPr>
+          <p:cNvPr id="35" name="TextBox 34"/>
           <p:cNvSpPr txBox="1"/>
           <p:nvPr/>
         </p:nvSpPr>
         <p:spPr>
           <a:xfrm>
-            <a:off x="4389120" y="4946903"/>
-            <a:ext cx="1645920" cy="228600"/>
+            <a:off x="365760" y="5303520"/>
+            <a:ext cx="5943600" cy="228600"/>
           </a:xfrm>
           <a:prstGeom prst="rect">
             <a:avLst/>
@@ -4413,29 +4561,29 @@
           <a:lstStyle/>
           <a:p>
             <a:pPr algn="l">
-              <a:defRPr sz="1200" b="1">
-                <a:solidFill>
-                  <a:srgbClr val="FF6B00"/>
+              <a:defRPr sz="1150" b="1">
+                <a:solidFill>
+                  <a:srgbClr val="00E5FF"/>
                 </a:solidFill>
                 <a:latin typeface="Calibri"/>
               </a:defRPr>
             </a:pPr>
             <a:r>
-              <a:t>867 hrs SAVED </a:t>
-            </a:r>
-          </a:p>
-        </p:txBody>
-      </p:sp>
-      <p:sp>
-        <p:nvSpPr>
-          <p:cNvPr id="34" name="TextBox 33"/>
+              <a:t>Real Saving — NG-FMS ATS Core EPP</a:t>
+            </a:r>
+          </a:p>
+        </p:txBody>
+      </p:sp>
+      <p:sp>
+        <p:nvSpPr>
+          <p:cNvPr id="36" name="TextBox 35"/>
           <p:cNvSpPr txBox="1"/>
           <p:nvPr/>
         </p:nvSpPr>
         <p:spPr>
           <a:xfrm>
-            <a:off x="5577840" y="4946903"/>
-            <a:ext cx="1371600" cy="228600"/>
+            <a:off x="365760" y="5541264"/>
+            <a:ext cx="5943600" cy="201168"/>
           </a:xfrm>
           <a:prstGeom prst="rect">
             <a:avLst/>
@@ -4449,29 +4597,29 @@
           <a:lstStyle/>
           <a:p>
             <a:pPr algn="l">
-              <a:defRPr sz="1200" b="1">
-                <a:solidFill>
-                  <a:srgbClr val="FFCC00"/>
+              <a:defRPr sz="1050" b="0">
+                <a:solidFill>
+                  <a:srgbClr val="FFFFFF"/>
                 </a:solidFill>
                 <a:latin typeface="Calibri"/>
               </a:defRPr>
             </a:pPr>
             <a:r>
-              <a:t>*($30k)*</a:t>
-            </a:r>
-          </a:p>
-        </p:txBody>
-      </p:sp>
-      <p:sp>
-        <p:nvSpPr>
-          <p:cNvPr id="35" name="TextBox 34"/>
+              <a:t>• 143 defects analysed + pushed in the EPP</a:t>
+            </a:r>
+          </a:p>
+        </p:txBody>
+      </p:sp>
+      <p:sp>
+        <p:nvSpPr>
+          <p:cNvPr id="37" name="TextBox 36"/>
           <p:cNvSpPr txBox="1"/>
           <p:nvPr/>
         </p:nvSpPr>
         <p:spPr>
           <a:xfrm>
-            <a:off x="457200" y="5202935"/>
-            <a:ext cx="5943600" cy="228600"/>
+            <a:off x="365760" y="5760720"/>
+            <a:ext cx="6858000" cy="201168"/>
           </a:xfrm>
           <a:prstGeom prst="rect">
             <a:avLst/>
@@ -4485,28 +4633,28 @@
           <a:lstStyle/>
           <a:p>
             <a:pPr algn="l">
-              <a:defRPr sz="1200" b="1">
-                <a:solidFill>
-                  <a:srgbClr val="00CCFF"/>
+              <a:defRPr sz="1050" b="0">
+                <a:solidFill>
+                  <a:srgbClr val="D7DEEB"/>
                 </a:solidFill>
                 <a:latin typeface="Calibri"/>
               </a:defRPr>
             </a:pPr>
             <a:r>
-              <a:t>Real Saving — NG-FMS ATS Core EPP</a:t>
-            </a:r>
-          </a:p>
-        </p:txBody>
-      </p:sp>
-      <p:sp>
-        <p:nvSpPr>
-          <p:cNvPr id="36" name="TextBox 35"/>
+              <a:t>• Manual push: 143 min (≈1 min per defect)   →   Tool push: ~3 min (one batch)</a:t>
+            </a:r>
+          </a:p>
+        </p:txBody>
+      </p:sp>
+      <p:sp>
+        <p:nvSpPr>
+          <p:cNvPr id="38" name="TextBox 37"/>
           <p:cNvSpPr txBox="1"/>
           <p:nvPr/>
         </p:nvSpPr>
         <p:spPr>
           <a:xfrm>
-            <a:off x="457200" y="5440679"/>
+            <a:off x="365760" y="5980176"/>
             <a:ext cx="5943600" cy="201168"/>
           </a:xfrm>
           <a:prstGeom prst="rect">
@@ -4521,29 +4669,29 @@
           <a:lstStyle/>
           <a:p>
             <a:pPr algn="l">
-              <a:defRPr sz="1100" b="0">
-                <a:solidFill>
-                  <a:srgbClr val="FFFFFF"/>
+              <a:defRPr sz="1050" b="1">
+                <a:solidFill>
+                  <a:srgbClr val="32FF82"/>
                 </a:solidFill>
                 <a:latin typeface="Calibri"/>
               </a:defRPr>
             </a:pPr>
             <a:r>
-              <a:t>• 143 defects analysed + pushed in the EPP</a:t>
-            </a:r>
-          </a:p>
-        </p:txBody>
-      </p:sp>
-      <p:sp>
-        <p:nvSpPr>
-          <p:cNvPr id="37" name="TextBox 36"/>
+              <a:t>• Saved on push: ~140 min ($84) (≈99% faster, 2.4 hrs)</a:t>
+            </a:r>
+          </a:p>
+        </p:txBody>
+      </p:sp>
+      <p:sp>
+        <p:nvSpPr>
+          <p:cNvPr id="39" name="TextBox 38"/>
           <p:cNvSpPr txBox="1"/>
           <p:nvPr/>
         </p:nvSpPr>
         <p:spPr>
           <a:xfrm>
-            <a:off x="457200" y="5660136"/>
-            <a:ext cx="6858000" cy="201168"/>
+            <a:off x="365760" y="6217920"/>
+            <a:ext cx="10972800" cy="228600"/>
           </a:xfrm>
           <a:prstGeom prst="rect">
             <a:avLst/>
@@ -4557,81 +4705,9 @@
           <a:lstStyle/>
           <a:p>
             <a:pPr algn="l">
-              <a:defRPr sz="1100" b="0">
-                <a:solidFill>
-                  <a:srgbClr val="CCCCDD"/>
-                </a:solidFill>
-                <a:latin typeface="Calibri"/>
-              </a:defRPr>
-            </a:pPr>
-            <a:r>
-              <a:t>• Manual push: 143 min (≈1 min per defect)   →   Tool push: ~3 min (one batch)</a:t>
-            </a:r>
-          </a:p>
-        </p:txBody>
-      </p:sp>
-      <p:sp>
-        <p:nvSpPr>
-          <p:cNvPr id="38" name="TextBox 37"/>
-          <p:cNvSpPr txBox="1"/>
-          <p:nvPr/>
-        </p:nvSpPr>
-        <p:spPr>
-          <a:xfrm>
-            <a:off x="457200" y="5879592"/>
-            <a:ext cx="5943600" cy="201168"/>
-          </a:xfrm>
-          <a:prstGeom prst="rect">
-            <a:avLst/>
-          </a:prstGeom>
-          <a:noFill/>
-        </p:spPr>
-        <p:txBody>
-          <a:bodyPr wrap="square" anchor="t">
-            <a:spAutoFit/>
-          </a:bodyPr>
-          <a:lstStyle/>
-          <a:p>
-            <a:pPr algn="l">
-              <a:defRPr sz="1100" b="1">
-                <a:solidFill>
-                  <a:srgbClr val="33FF88"/>
-                </a:solidFill>
-                <a:latin typeface="Calibri"/>
-              </a:defRPr>
-            </a:pPr>
-            <a:r>
-              <a:t>• Saved on push: ~140 min ($84) (≈99% faster, 2.4 hrs)</a:t>
-            </a:r>
-          </a:p>
-        </p:txBody>
-      </p:sp>
-      <p:sp>
-        <p:nvSpPr>
-          <p:cNvPr id="39" name="TextBox 38"/>
-          <p:cNvSpPr txBox="1"/>
-          <p:nvPr/>
-        </p:nvSpPr>
-        <p:spPr>
-          <a:xfrm>
-            <a:off x="457200" y="6135624"/>
-            <a:ext cx="10972800" cy="228600"/>
-          </a:xfrm>
-          <a:prstGeom prst="rect">
-            <a:avLst/>
-          </a:prstGeom>
-          <a:noFill/>
-        </p:spPr>
-        <p:txBody>
-          <a:bodyPr wrap="square" anchor="t">
-            <a:spAutoFit/>
-          </a:bodyPr>
-          <a:lstStyle/>
-          <a:p>
-            <a:pPr algn="l">
-              <a:defRPr sz="1100" b="1">
-                <a:solidFill>
-                  <a:srgbClr val="FF9933"/>
+              <a:defRPr sz="1050" b="1">
+                <a:solidFill>
+                  <a:srgbClr val="00E5FF"/>
                 </a:solidFill>
                 <a:latin typeface="Calibri"/>
               </a:defRPr>
@@ -4661,7 +4737,7 @@
           </a:solidFill>
           <a:ln w="19050">
             <a:solidFill>
-              <a:srgbClr val="00CCFF"/>
+              <a:srgbClr val="00E5FF"/>
             </a:solidFill>
           </a:ln>
         </p:spPr>
@@ -4741,7 +4817,7 @@
             <a:pPr algn="ctr">
               <a:defRPr sz="900" b="0">
                 <a:solidFill>
-                  <a:srgbClr val="CCCCDD"/>
+                  <a:srgbClr val="D7DEEB"/>
                 </a:solidFill>
                 <a:latin typeface="Calibri"/>
               </a:defRPr>
@@ -4767,7 +4843,7 @@
             <a:avLst/>
           </a:prstGeom>
           <a:solidFill>
-            <a:srgbClr val="FF6B00"/>
+            <a:srgbClr val="FA7024"/>
           </a:solidFill>
           <a:ln>
             <a:noFill/>
@@ -4814,7 +4890,7 @@
           </a:solidFill>
           <a:ln w="19050">
             <a:solidFill>
-              <a:srgbClr val="00CCFF"/>
+              <a:srgbClr val="00E5FF"/>
             </a:solidFill>
           </a:ln>
         </p:spPr>
@@ -4847,7 +4923,7 @@
             <a:pPr algn="ctr">
               <a:defRPr sz="1000">
                 <a:solidFill>
-                  <a:srgbClr val="00CCFF"/>
+                  <a:srgbClr val="00E5FF"/>
                 </a:solidFill>
               </a:defRPr>
             </a:pPr>
@@ -4882,7 +4958,7 @@
             <a:pPr algn="ctr">
               <a:defRPr sz="900" b="0">
                 <a:solidFill>
-                  <a:srgbClr val="CCCCDD"/>
+                  <a:srgbClr val="D7DEEB"/>
                 </a:solidFill>
                 <a:latin typeface="Calibri"/>
               </a:defRPr>
@@ -4944,7 +5020,7 @@
             <a:avLst/>
           </a:prstGeom>
           <a:solidFill>
-            <a:srgbClr val="FF6B00"/>
+            <a:srgbClr val="FA7024"/>
           </a:solidFill>
           <a:ln>
             <a:noFill/>
@@ -4991,7 +5067,7 @@
           </a:solidFill>
           <a:ln w="19050">
             <a:solidFill>
-              <a:srgbClr val="FF6B00"/>
+              <a:srgbClr val="FA7024"/>
             </a:solidFill>
           </a:ln>
         </p:spPr>
@@ -5024,7 +5100,7 @@
             <a:pPr algn="ctr">
               <a:defRPr sz="1200" b="1">
                 <a:solidFill>
-                  <a:srgbClr val="FF6B00"/>
+                  <a:srgbClr val="FA7024"/>
                 </a:solidFill>
               </a:defRPr>
             </a:pPr>
@@ -5036,7 +5112,7 @@
             <a:pPr algn="ctr">
               <a:defRPr sz="900">
                 <a:solidFill>
-                  <a:srgbClr val="CCCCDD"/>
+                  <a:srgbClr val="D7DEEB"/>
                 </a:solidFill>
               </a:defRPr>
             </a:pPr>
@@ -5071,7 +5147,7 @@
             <a:pPr algn="ctr">
               <a:defRPr sz="900" b="0">
                 <a:solidFill>
-                  <a:srgbClr val="CCCCDD"/>
+                  <a:srgbClr val="D7DEEB"/>
                 </a:solidFill>
                 <a:latin typeface="Calibri"/>
               </a:defRPr>
@@ -5097,7 +5173,7 @@
             <a:avLst/>
           </a:prstGeom>
           <a:solidFill>
-            <a:srgbClr val="FF6B00"/>
+            <a:srgbClr val="FA7024"/>
           </a:solidFill>
           <a:ln>
             <a:noFill/>
@@ -5224,7 +5300,7 @@
             <a:pPr algn="ctr">
               <a:defRPr sz="1300" b="1">
                 <a:solidFill>
-                  <a:srgbClr val="CCCCDD"/>
+                  <a:srgbClr val="D7DEEB"/>
                 </a:solidFill>
                 <a:latin typeface="Calibri"/>
               </a:defRPr>

</xml_diff>

<commit_message>
Update Cost Savings: replace Real Saving with Deployed in, remove analysed +, highlight $84 badge, match fonts with Core Features, and format future programs line
Co-authored-by: arena-agent <297053741+arena-agent@users.noreply.github.com>
</commit_message>
<xml_diff>
--- a/Coverity_Findings_Analyzer.pptx
+++ b/Coverity_Findings_Analyzer.pptx
@@ -4569,7 +4569,7 @@
               </a:defRPr>
             </a:pPr>
             <a:r>
-              <a:t>Real Saving — NG-FMS ATS Core EPP</a:t>
+              <a:t>Deployed in — NG-FMS ATS Core EPP</a:t>
             </a:r>
           </a:p>
         </p:txBody>
@@ -4605,7 +4605,7 @@
               </a:defRPr>
             </a:pPr>
             <a:r>
-              <a:t>• 143 defects analysed + pushed in the EPP</a:t>
+              <a:t>• 143 defects pushed in the EPP</a:t>
             </a:r>
           </a:p>
         </p:txBody>
@@ -4655,7 +4655,7 @@
         <p:spPr>
           <a:xfrm>
             <a:off x="365760" y="5980176"/>
-            <a:ext cx="5943600" cy="201168"/>
+            <a:ext cx="2286000" cy="201168"/>
           </a:xfrm>
           <a:prstGeom prst="rect">
             <a:avLst/>
@@ -4677,21 +4677,75 @@
               </a:defRPr>
             </a:pPr>
             <a:r>
-              <a:t>• Saved on push: ~140 min ($84) (≈99% faster, 2.4 hrs)</a:t>
-            </a:r>
-          </a:p>
-        </p:txBody>
-      </p:sp>
-      <p:sp>
-        <p:nvSpPr>
-          <p:cNvPr id="39" name="TextBox 38"/>
+              <a:t>• Saved on push: ~140 min</a:t>
+            </a:r>
+          </a:p>
+        </p:txBody>
+      </p:sp>
+      <p:sp>
+        <p:nvSpPr>
+          <p:cNvPr id="39" name="Rounded Rectangle 38"/>
+          <p:cNvSpPr/>
+          <p:nvPr/>
+        </p:nvSpPr>
+        <p:spPr>
+          <a:xfrm>
+            <a:off x="2651760" y="5943600"/>
+            <a:ext cx="1005840" cy="237744"/>
+          </a:xfrm>
+          <a:prstGeom prst="roundRect">
+            <a:avLst/>
+          </a:prstGeom>
+          <a:solidFill>
+            <a:srgbClr val="231C05"/>
+          </a:solidFill>
+          <a:ln w="19050">
+            <a:solidFill>
+              <a:srgbClr val="FFE114"/>
+            </a:solidFill>
+          </a:ln>
+        </p:spPr>
+        <p:style>
+          <a:lnRef idx="1">
+            <a:schemeClr val="accent1"/>
+          </a:lnRef>
+          <a:fillRef idx="3">
+            <a:schemeClr val="accent1"/>
+          </a:fillRef>
+          <a:effectRef idx="2">
+            <a:schemeClr val="accent1"/>
+          </a:effectRef>
+          <a:fontRef idx="minor">
+            <a:schemeClr val="lt1"/>
+          </a:fontRef>
+        </p:style>
+        <p:txBody>
+          <a:bodyPr rtlCol="0" anchor="ctr"/>
+          <a:lstStyle/>
+          <a:p>
+            <a:pPr algn="ctr">
+              <a:defRPr sz="1100" b="1">
+                <a:solidFill>
+                  <a:srgbClr val="FFE114"/>
+                </a:solidFill>
+              </a:defRPr>
+            </a:pPr>
+            <a:r>
+              <a:t>★ ($84) ★</a:t>
+            </a:r>
+          </a:p>
+        </p:txBody>
+      </p:sp>
+      <p:sp>
+        <p:nvSpPr>
+          <p:cNvPr id="40" name="TextBox 39"/>
           <p:cNvSpPr txBox="1"/>
           <p:nvPr/>
         </p:nvSpPr>
         <p:spPr>
           <a:xfrm>
-            <a:off x="365760" y="6217920"/>
-            <a:ext cx="10972800" cy="228600"/>
+            <a:off x="3749039" y="5980176"/>
+            <a:ext cx="3200400" cy="201168"/>
           </a:xfrm>
           <a:prstGeom prst="rect">
             <a:avLst/>
@@ -4707,20 +4761,56 @@
             <a:pPr algn="l">
               <a:defRPr sz="1050" b="1">
                 <a:solidFill>
+                  <a:srgbClr val="32FF82"/>
+                </a:solidFill>
+                <a:latin typeface="Calibri"/>
+              </a:defRPr>
+            </a:pPr>
+            <a:r>
+              <a:t>(≈99% faster, 2.4 hrs)</a:t>
+            </a:r>
+          </a:p>
+        </p:txBody>
+      </p:sp>
+      <p:sp>
+        <p:nvSpPr>
+          <p:cNvPr id="41" name="TextBox 40"/>
+          <p:cNvSpPr txBox="1"/>
+          <p:nvPr/>
+        </p:nvSpPr>
+        <p:spPr>
+          <a:xfrm>
+            <a:off x="365760" y="6236208"/>
+            <a:ext cx="11430000" cy="228600"/>
+          </a:xfrm>
+          <a:prstGeom prst="rect">
+            <a:avLst/>
+          </a:prstGeom>
+          <a:noFill/>
+        </p:spPr>
+        <p:txBody>
+          <a:bodyPr wrap="square" anchor="t">
+            <a:spAutoFit/>
+          </a:bodyPr>
+          <a:lstStyle/>
+          <a:p>
+            <a:pPr algn="l">
+              <a:defRPr sz="1050" b="1">
+                <a:solidFill>
                   <a:srgbClr val="00E5FF"/>
                 </a:solidFill>
                 <a:latin typeface="Calibri"/>
               </a:defRPr>
             </a:pPr>
             <a:r>
-              <a:t>Future Targeted programs are  Datalink(787,AIMS,EPIC), TXD along all CNS products and all other HonAero Departments....</a:t>
-            </a:r>
-          </a:p>
-        </p:txBody>
-      </p:sp>
-      <p:sp>
-        <p:nvSpPr>
-          <p:cNvPr id="40" name="Rounded Rectangle 39"/>
+              <a:t>Future Targeted Programs: Datalink (787, AIMS, EPIC), TXD across all CNS products, and all other HonAero Departments...</a:t>
+            </a:r>
+          </a:p>
+        </p:txBody>
+      </p:sp>
+      <p:sp>
+        <p:nvSpPr>
+          <p:cNvPr id="42" name="Rounded Rectangle 41"/>
           <p:cNvSpPr/>
           <p:nvPr/>
         </p:nvSpPr>
@@ -4794,7 +4884,7 @@
       </p:sp>
       <p:sp>
         <p:nvSpPr>
-          <p:cNvPr id="41" name="TextBox 40"/>
+          <p:cNvPr id="43" name="TextBox 42"/>
           <p:cNvSpPr txBox="1"/>
           <p:nvPr/>
         </p:nvSpPr>
@@ -4830,7 +4920,7 @@
       </p:sp>
       <p:sp>
         <p:nvSpPr>
-          <p:cNvPr id="42" name="Right Arrow 41"/>
+          <p:cNvPr id="44" name="Right Arrow 43"/>
           <p:cNvSpPr/>
           <p:nvPr/>
         </p:nvSpPr>
@@ -4873,7 +4963,7 @@
       </p:sp>
       <p:sp>
         <p:nvSpPr>
-          <p:cNvPr id="43" name="Rounded Rectangle 42"/>
+          <p:cNvPr id="45" name="Rounded Rectangle 44"/>
           <p:cNvSpPr/>
           <p:nvPr/>
         </p:nvSpPr>
@@ -4935,7 +5025,7 @@
       </p:sp>
       <p:sp>
         <p:nvSpPr>
-          <p:cNvPr id="44" name="TextBox 43"/>
+          <p:cNvPr id="46" name="TextBox 45"/>
           <p:cNvSpPr txBox="1"/>
           <p:nvPr/>
         </p:nvSpPr>
@@ -4971,7 +5061,7 @@
       </p:sp>
       <p:sp>
         <p:nvSpPr>
-          <p:cNvPr id="45" name="TextBox 44"/>
+          <p:cNvPr id="47" name="TextBox 46"/>
           <p:cNvSpPr txBox="1"/>
           <p:nvPr/>
         </p:nvSpPr>
@@ -5007,7 +5097,7 @@
       </p:sp>
       <p:sp>
         <p:nvSpPr>
-          <p:cNvPr id="46" name="Down Arrow 45"/>
+          <p:cNvPr id="48" name="Down Arrow 47"/>
           <p:cNvSpPr/>
           <p:nvPr/>
         </p:nvSpPr>
@@ -5050,7 +5140,7 @@
       </p:sp>
       <p:sp>
         <p:nvSpPr>
-          <p:cNvPr id="47" name="Rounded Rectangle 46"/>
+          <p:cNvPr id="49" name="Rounded Rectangle 48"/>
           <p:cNvSpPr/>
           <p:nvPr/>
         </p:nvSpPr>
@@ -5124,7 +5214,7 @@
       </p:sp>
       <p:sp>
         <p:nvSpPr>
-          <p:cNvPr id="48" name="TextBox 47"/>
+          <p:cNvPr id="50" name="TextBox 49"/>
           <p:cNvSpPr txBox="1"/>
           <p:nvPr/>
         </p:nvSpPr>
@@ -5160,7 +5250,7 @@
       </p:sp>
       <p:sp>
         <p:nvSpPr>
-          <p:cNvPr id="49" name="Down Arrow 48"/>
+          <p:cNvPr id="51" name="Down Arrow 50"/>
           <p:cNvSpPr/>
           <p:nvPr/>
         </p:nvSpPr>
@@ -5203,7 +5293,7 @@
       </p:sp>
       <p:sp>
         <p:nvSpPr>
-          <p:cNvPr id="50" name="Rounded Rectangle 49"/>
+          <p:cNvPr id="52" name="Rounded Rectangle 51"/>
           <p:cNvSpPr/>
           <p:nvPr/>
         </p:nvSpPr>
@@ -5277,7 +5367,7 @@
       </p:sp>
       <p:sp>
         <p:nvSpPr>
-          <p:cNvPr id="51" name="TextBox 50"/>
+          <p:cNvPr id="53" name="TextBox 52"/>
           <p:cNvSpPr txBox="1"/>
           <p:nvPr/>
         </p:nvSpPr>

</xml_diff>